<commit_message>
docs(recruiting): Kundenfolien decken die ganze Anleitung vom 06.10. ab plus Neuerungen 08.10.
Kampagne wieder mit allen sechs Schritten, Gut zu wissen vollstaendig
(Ausschreibungswechsel, Vorlage pflegen, wer bekommt sie), Satz zur
Erinnerung beim Verschieben; Textfolien ohne Platzhalter, wenn ein
Screenshot fehlt.

Co-Authored-By: Claude Opus 5.5 <noreply@anthropic.com>
</commit_message>
<xml_diff>
--- a/docs/anleitungen/folien/2026-10-08-schulungstermine-umplanen.pptx
+++ b/docs/anleitungen/folien/2026-10-08-schulungstermine-umplanen.pptx
@@ -12,6 +12,8 @@
     <p:sldId id="260" r:id="rId11"/>
     <p:sldId id="261" r:id="rId12"/>
     <p:sldId id="262" r:id="rId13"/>
+    <p:sldId id="263" r:id="rId14"/>
+    <p:sldId id="264" r:id="rId15"/>
   </p:sldIdLst>
   <p:sldSz cx="12192000" cy="6858000" type="screen4x3"/>
   <p:notesSz cx="6858000" cy="9144000"/>
@@ -3171,7 +3173,7 @@
                 </a:solidFill>
                 <a:latin typeface="Calibri"/>
               </a:rPr>
-              <a:t>SCHRITT 1 · TEILNEHMER VERSCHIEBEN</a:t>
+              <a:t>TEILNEHMER VERSCHIEBEN · SCHRITT 1</a:t>
             </a:r>
           </a:p>
         </p:txBody>
@@ -3345,7 +3347,7 @@
         <p:spPr>
           <a:xfrm>
             <a:off x="685800" y="1773936"/>
-            <a:ext cx="3291840" cy="3840480"/>
+            <a:ext cx="3291840" cy="3657600"/>
           </a:xfrm>
           <a:prstGeom prst="rect">
             <a:avLst/>
@@ -3388,7 +3390,7 @@
                 </a:solidFill>
                 <a:latin typeface="Calibri"/>
               </a:rPr>
-              <a:t> öffnen und den Termin anklicken, aus dem ihr verschieben wollt.</a:t>
+              <a:t> öffnen und den Termin anklicken, aus dem ihr verschieben wollt (Schulung A).</a:t>
             </a:r>
           </a:p>
           <a:p>
@@ -3422,7 +3424,7 @@
                 </a:solidFill>
                 <a:latin typeface="Calibri"/>
               </a:rPr>
-              <a:t>. Das Kästchen in der Kopfzeile wählt alle auf einmal.</a:t>
+              <a:t>. Das Kästchen oben in der Kopfzeile wählt alle verschiebbaren auf einmal.</a:t>
             </a:r>
           </a:p>
           <a:p>
@@ -3438,7 +3440,7 @@
                 </a:solidFill>
                 <a:latin typeface="Calibri"/>
               </a:rPr>
-              <a:t>3. Im blauen Balken auf </a:t>
+              <a:t>3. Oben erscheint der blaue Balken „N ausgewählt“. Dort auf </a:t>
             </a:r>
             <a:r>
               <a:rPr sz="1700" b="1">
@@ -3469,8 +3471,8 @@
         </p:nvSpPr>
         <p:spPr>
           <a:xfrm>
-            <a:off x="685800" y="5394960"/>
-            <a:ext cx="3291840" cy="822960"/>
+            <a:off x="685800" y="5257800"/>
+            <a:ext cx="3291840" cy="1005840"/>
           </a:xfrm>
           <a:prstGeom prst="rect">
             <a:avLst/>
@@ -3485,17 +3487,17 @@
           <a:p>
             <a:pPr algn="l">
               <a:spcAft>
-                <a:spcPts val="1019"/>
+                <a:spcPts val="960"/>
               </a:spcAft>
             </a:pPr>
             <a:r>
-              <a:rPr sz="1700" b="1">
+              <a:rPr sz="1600" b="1">
                 <a:solidFill>
                   <a:srgbClr val="1273DE"/>
                 </a:solidFill>
                 <a:latin typeface="Calibri"/>
               </a:rPr>
-              <a:t>Geht vorher und während der Schulung.</a:t>
+              <a:t>Geht vorher und auch während der Schulung.</a:t>
             </a:r>
           </a:p>
         </p:txBody>
@@ -3516,7 +3518,7 @@
         </p:blipFill>
         <p:spPr>
           <a:xfrm>
-            <a:off x="4160520" y="2366088"/>
+            <a:off x="4160520" y="2338656"/>
             <a:ext cx="7360920" cy="3277966"/>
           </a:xfrm>
           <a:prstGeom prst="rect">
@@ -3624,7 +3626,7 @@
                 </a:solidFill>
                 <a:latin typeface="Calibri"/>
               </a:rPr>
-              <a:t>SCHRITT 2 · TEILNEHMER VERSCHIEBEN</a:t>
+              <a:t>TEILNEHMER VERSCHIEBEN · SCHRITT 2</a:t>
             </a:r>
           </a:p>
         </p:txBody>
@@ -3663,7 +3665,7 @@
                 </a:solidFill>
                 <a:latin typeface="Calibri"/>
               </a:rPr>
-              <a:t>Zieltermin wählen</a:t>
+              <a:t>Zieltermin wählen und verschieben</a:t>
             </a:r>
           </a:p>
         </p:txBody>
@@ -3798,7 +3800,7 @@
         <p:spPr>
           <a:xfrm>
             <a:off x="685800" y="1773936"/>
-            <a:ext cx="3291840" cy="3840480"/>
+            <a:ext cx="3291840" cy="3657600"/>
           </a:xfrm>
           <a:prstGeom prst="rect">
             <a:avLst/>
@@ -3823,7 +3825,7 @@
                 </a:solidFill>
                 <a:latin typeface="Calibri"/>
               </a:rPr>
-              <a:t>4. Den </a:t>
+              <a:t>4. Im Fenster den </a:t>
             </a:r>
             <a:r>
               <a:rPr sz="1700" b="1">
@@ -3841,7 +3843,7 @@
                 </a:solidFill>
                 <a:latin typeface="Calibri"/>
               </a:rPr>
-              <a:t> wählen. Hinter jedem Termin steht, wie viele Plätze frei sind.</a:t>
+              <a:t> wählen (Schulung B). Hinter jedem Termin steht, wie viele Plätze noch frei sind.</a:t>
             </a:r>
           </a:p>
           <a:p>
@@ -3875,7 +3877,7 @@
                 </a:solidFill>
                 <a:latin typeface="Calibri"/>
               </a:rPr>
-              <a:t> eintragen, z. B. „Logistik-Gruppe“. Er steht im Verlauf.</a:t>
+              <a:t> eintragen, z. B. „Logistik-Gruppe“. Er steht später im Verlauf des Bewerbers.</a:t>
             </a:r>
           </a:p>
           <a:p>
@@ -3909,7 +3911,7 @@
                 </a:solidFill>
                 <a:latin typeface="Calibri"/>
               </a:rPr>
-              <a:t> klicken.</a:t>
+              <a:t> klicken. Fertig.</a:t>
             </a:r>
           </a:p>
         </p:txBody>
@@ -3922,7 +3924,7 @@
         </p:nvSpPr>
         <p:spPr>
           <a:xfrm>
-            <a:off x="685800" y="5212080"/>
+            <a:off x="685800" y="5257800"/>
             <a:ext cx="3291840" cy="1005840"/>
           </a:xfrm>
           <a:prstGeom prst="rect">
@@ -3938,17 +3940,17 @@
           <a:p>
             <a:pPr algn="l">
               <a:spcAft>
-                <a:spcPts val="1019"/>
+                <a:spcPts val="960"/>
               </a:spcAft>
             </a:pPr>
             <a:r>
-              <a:rPr sz="1700" b="1">
+              <a:rPr sz="1600" b="1">
                 <a:solidFill>
                   <a:srgbClr val="1273DE"/>
                 </a:solidFill>
                 <a:latin typeface="Calibri"/>
               </a:rPr>
-              <a:t>Status, Bestätigung und Notizen bleiben. Es geht keine Nachricht raus.</a:t>
+              <a:t>Status, Bestätigung und Notizen bleiben. Wer schon erinnert wurde, bekommt keine zweite Erinnerung. Es geht keine Nachricht raus.</a:t>
             </a:r>
           </a:p>
         </p:txBody>
@@ -3969,8 +3971,8 @@
         </p:blipFill>
         <p:spPr>
           <a:xfrm>
-            <a:off x="4344439" y="1719072"/>
-            <a:ext cx="6993081" cy="4572000"/>
+            <a:off x="4386397" y="1719072"/>
+            <a:ext cx="6909164" cy="4517136"/>
           </a:xfrm>
           <a:prstGeom prst="rect">
             <a:avLst/>
@@ -4077,7 +4079,7 @@
                 </a:solidFill>
                 <a:latin typeface="Calibri"/>
               </a:rPr>
-              <a:t>AM SCHULUNGSABEND</a:t>
+              <a:t>NEU · WÄHREND DER SCHULUNG</a:t>
             </a:r>
           </a:p>
         </p:txBody>
@@ -4116,7 +4118,7 @@
                 </a:solidFill>
                 <a:latin typeface="Calibri"/>
               </a:rPr>
-              <a:t>Erst „Teilgenommen“, dann aufteilen</a:t>
+              <a:t>Erst „Teilgenommen“, dann in Gruppen aufteilen</a:t>
             </a:r>
           </a:p>
         </p:txBody>
@@ -4266,20 +4268,20 @@
           <a:p>
             <a:pPr algn="l">
               <a:spcAft>
-                <a:spcPts val="1200"/>
+                <a:spcPts val="1080"/>
               </a:spcAft>
             </a:pPr>
             <a:r>
-              <a:rPr sz="2000" b="0">
+              <a:rPr sz="1800" b="0">
                 <a:solidFill>
                   <a:srgbClr val="111111"/>
                 </a:solidFill>
                 <a:latin typeface="Calibri"/>
               </a:rPr>
-              <a:t>In der großen Gruppe alle Anwesenden auf </a:t>
-            </a:r>
-            <a:r>
-              <a:rPr sz="2000" b="1">
+              <a:t>Verschieben geht jetzt auch, während der Termin läuft, und auch mit Teilnehmern, die schon auf </a:t>
+            </a:r>
+            <a:r>
+              <a:rPr sz="1800" b="1">
                 <a:solidFill>
                   <a:srgbClr val="111111"/>
                 </a:solidFill>
@@ -4288,13 +4290,13 @@
               <a:t>Teilgenommen</a:t>
             </a:r>
             <a:r>
-              <a:rPr sz="2000" b="0">
+              <a:rPr sz="1800" b="0">
                 <a:solidFill>
                   <a:srgbClr val="111111"/>
                 </a:solidFill>
                 <a:latin typeface="Calibri"/>
               </a:rPr>
-              <a:t> setzen. Danach in die Gruppen verschieben. Der Status wandert mit.</a:t>
+              <a:t> stehen. In der großen Gruppe alle Anwesenden auf Teilgenommen setzen, danach in die Gruppen verschieben. Der Status wandert mit.</a:t>
             </a:r>
           </a:p>
         </p:txBody>
@@ -4315,7 +4317,7 @@
         </p:blipFill>
         <p:spPr>
           <a:xfrm>
-            <a:off x="685800" y="2832358"/>
+            <a:off x="685800" y="2891794"/>
             <a:ext cx="7287768" cy="3131810"/>
           </a:xfrm>
           <a:prstGeom prst="rect">
@@ -4423,17 +4425,17 @@
           <a:p>
             <a:pPr algn="l">
               <a:spcAft>
-                <a:spcPts val="960"/>
+                <a:spcPts val="900"/>
               </a:spcAft>
             </a:pPr>
             <a:r>
-              <a:rPr sz="1600" b="0">
+              <a:rPr sz="1500" b="0">
                 <a:solidFill>
                   <a:srgbClr val="111111"/>
                 </a:solidFill>
                 <a:latin typeface="Calibri"/>
               </a:rPr>
-              <a:t>Volle Gruppe: Wer nicht mehr passt, bleibt im alten Termin.</a:t>
+              <a:t>Im Zieltermin steht an der Person „aus …“ mit dem alten Termin.</a:t>
             </a:r>
           </a:p>
         </p:txBody>
@@ -4533,7 +4535,7 @@
                 </a:solidFill>
                 <a:latin typeface="Calibri"/>
               </a:rPr>
-              <a:t>NACH DER SCHULUNG</a:t>
+              <a:t>VOR DER SCHULUNG</a:t>
             </a:r>
           </a:p>
         </p:txBody>
@@ -4572,7 +4574,7 @@
                 </a:solidFill>
                 <a:latin typeface="Calibri"/>
               </a:rPr>
-              <a:t>Vertragsdaten eintragen, auch zu zweit</a:t>
+              <a:t>Nach Status filtern, auch „Keine Reaktion“</a:t>
             </a:r>
           </a:p>
         </p:txBody>
@@ -4707,7 +4709,7 @@
         <p:spPr>
           <a:xfrm>
             <a:off x="685800" y="1773936"/>
-            <a:ext cx="3291840" cy="3840480"/>
+            <a:ext cx="3291840" cy="3657600"/>
           </a:xfrm>
           <a:prstGeom prst="rect">
             <a:avLst/>
@@ -4732,7 +4734,7 @@
                 </a:solidFill>
                 <a:latin typeface="Calibri"/>
               </a:rPr>
-              <a:t>1. Den Termin öffnen, Reiter </a:t>
+              <a:t>Oben in der Liste das Feld </a:t>
             </a:r>
             <a:r>
               <a:rPr sz="1700" b="1">
@@ -4741,7 +4743,7 @@
                 </a:solidFill>
                 <a:latin typeface="Calibri"/>
               </a:rPr>
-              <a:t>„Nach der Schulung“</a:t>
+              <a:t>Status</a:t>
             </a:r>
             <a:r>
               <a:rPr sz="1700" b="0">
@@ -4750,7 +4752,7 @@
                 </a:solidFill>
                 <a:latin typeface="Calibri"/>
               </a:rPr>
-              <a:t>.</a:t>
+              <a:t> öffnen. Der Filter gilt in der Übersicht und im Reiter „Nach der Schulung“.</a:t>
             </a:r>
           </a:p>
           <a:p>
@@ -4760,101 +4762,22 @@
               </a:spcAft>
             </a:pPr>
             <a:r>
+              <a:rPr sz="1700" b="1">
+                <a:solidFill>
+                  <a:srgbClr val="111111"/>
+                </a:solidFill>
+                <a:latin typeface="Calibri"/>
+              </a:rPr>
+              <a:t>Keine Reaktion</a:t>
+            </a:r>
+            <a:r>
               <a:rPr sz="1700" b="0">
                 <a:solidFill>
                   <a:srgbClr val="111111"/>
                 </a:solidFill>
                 <a:latin typeface="Calibri"/>
               </a:rPr>
-              <a:t>2. </a:t>
-            </a:r>
-            <a:r>
-              <a:rPr sz="1700" b="1">
-                <a:solidFill>
-                  <a:srgbClr val="111111"/>
-                </a:solidFill>
-                <a:latin typeface="Calibri"/>
-              </a:rPr>
-              <a:t>Zuschlag</a:t>
-            </a:r>
-            <a:r>
-              <a:rPr sz="1700" b="0">
-                <a:solidFill>
-                  <a:srgbClr val="111111"/>
-                </a:solidFill>
-                <a:latin typeface="Calibri"/>
-              </a:rPr>
-              <a:t>, </a:t>
-            </a:r>
-            <a:r>
-              <a:rPr sz="1700" b="1">
-                <a:solidFill>
-                  <a:srgbClr val="111111"/>
-                </a:solidFill>
-                <a:latin typeface="Calibri"/>
-              </a:rPr>
-              <a:t>Vertragsbeginn</a:t>
-            </a:r>
-            <a:r>
-              <a:rPr sz="1700" b="0">
-                <a:solidFill>
-                  <a:srgbClr val="111111"/>
-                </a:solidFill>
-                <a:latin typeface="Calibri"/>
-              </a:rPr>
-              <a:t> und bei Bedarf </a:t>
-            </a:r>
-            <a:r>
-              <a:rPr sz="1700" b="1">
-                <a:solidFill>
-                  <a:srgbClr val="111111"/>
-                </a:solidFill>
-                <a:latin typeface="Calibri"/>
-              </a:rPr>
-              <a:t>Vertragsende</a:t>
-            </a:r>
-            <a:r>
-              <a:rPr sz="1700" b="0">
-                <a:solidFill>
-                  <a:srgbClr val="111111"/>
-                </a:solidFill>
-                <a:latin typeface="Calibri"/>
-              </a:rPr>
-              <a:t> eintragen. Ohne Ende rechnet das System es aus.</a:t>
-            </a:r>
-          </a:p>
-          <a:p>
-            <a:pPr algn="l">
-              <a:spcAft>
-                <a:spcPts val="1019"/>
-              </a:spcAft>
-            </a:pPr>
-            <a:r>
-              <a:rPr sz="1700" b="0">
-                <a:solidFill>
-                  <a:srgbClr val="111111"/>
-                </a:solidFill>
-                <a:latin typeface="Calibri"/>
-              </a:rPr>
-              <a:t>3. Zum Schluss die Verträge über den </a:t>
-            </a:r>
-            <a:r>
-              <a:rPr sz="1700" b="1">
-                <a:solidFill>
-                  <a:srgbClr val="111111"/>
-                </a:solidFill>
-                <a:latin typeface="Calibri"/>
-              </a:rPr>
-              <a:t>Sammelversand</a:t>
-            </a:r>
-            <a:r>
-              <a:rPr sz="1700" b="0">
-                <a:solidFill>
-                  <a:srgbClr val="111111"/>
-                </a:solidFill>
-                <a:latin typeface="Calibri"/>
-              </a:rPr>
-              <a:t> schicken.</a:t>
+              <a:t> zeigt Gebuchte, die auf die Erinnerungen nicht reagiert haben. Ihr Platz ist wieder frei.</a:t>
             </a:r>
           </a:p>
         </p:txBody>
@@ -4867,8 +4790,8 @@
         </p:nvSpPr>
         <p:spPr>
           <a:xfrm>
-            <a:off x="685800" y="5120640"/>
-            <a:ext cx="3291840" cy="1097280"/>
+            <a:off x="685800" y="5257800"/>
+            <a:ext cx="3291840" cy="1005840"/>
           </a:xfrm>
           <a:prstGeom prst="rect">
             <a:avLst/>
@@ -4883,24 +4806,24 @@
           <a:p>
             <a:pPr algn="l">
               <a:spcAft>
-                <a:spcPts val="1019"/>
+                <a:spcPts val="960"/>
               </a:spcAft>
             </a:pPr>
             <a:r>
-              <a:rPr sz="1700" b="1">
+              <a:rPr sz="1600" b="1">
                 <a:solidFill>
                   <a:srgbClr val="1273DE"/>
                 </a:solidFill>
                 <a:latin typeface="Calibri"/>
               </a:rPr>
-              <a:t>Jede Eingabe ist sofort gespeichert. Zwei Laptops sehen denselben Stand.</a:t>
+              <a:t>Praktisch zum Nachtelefonieren vor der Schulung.</a:t>
             </a:r>
           </a:p>
         </p:txBody>
       </p:sp>
       <p:pic>
         <p:nvPicPr>
-          <p:cNvPr id="10" name="Picture 9" descr="D_nach_der_schulung.png"/>
+          <p:cNvPr id="10" name="Picture 9" descr="E_statusfilter.png"/>
           <p:cNvPicPr>
             <a:picLocks noChangeAspect="1"/>
           </p:cNvPicPr>
@@ -4914,8 +4837,8 @@
         </p:blipFill>
         <p:spPr>
           <a:xfrm>
-            <a:off x="4160520" y="2206195"/>
-            <a:ext cx="7360920" cy="3597753"/>
+            <a:off x="4160520" y="1875055"/>
+            <a:ext cx="7360920" cy="4205169"/>
           </a:xfrm>
           <a:prstGeom prst="rect">
             <a:avLst/>
@@ -5022,7 +4945,7 @@
                 </a:solidFill>
                 <a:latin typeface="Calibri"/>
               </a:rPr>
-              <a:t>ÜBERBLICK BEHALTEN</a:t>
+              <a:t>WENN EINE SCHULUNG VOLL IST · SCHRITT 1</a:t>
             </a:r>
           </a:p>
         </p:txBody>
@@ -5061,7 +4984,7 @@
                 </a:solidFill>
                 <a:latin typeface="Calibri"/>
               </a:rPr>
-              <a:t>Nach Status filtern, auch „Keine Reaktion“</a:t>
+              <a:t>Bewerber ohne Termin finden</a:t>
             </a:r>
           </a:p>
         </p:txBody>
@@ -5195,8 +5118,8 @@
         </p:nvSpPr>
         <p:spPr>
           <a:xfrm>
-            <a:off x="685800" y="1773936"/>
-            <a:ext cx="3291840" cy="3840480"/>
+            <a:off x="685800" y="1600200"/>
+            <a:ext cx="10789920" cy="731520"/>
           </a:xfrm>
           <a:prstGeom prst="rect">
             <a:avLst/>
@@ -5211,60 +5134,17 @@
           <a:p>
             <a:pPr algn="l">
               <a:spcAft>
-                <a:spcPts val="1019"/>
+                <a:spcPts val="960"/>
               </a:spcAft>
             </a:pPr>
             <a:r>
-              <a:rPr sz="1700" b="0">
-                <a:solidFill>
-                  <a:srgbClr val="111111"/>
-                </a:solidFill>
-                <a:latin typeface="Calibri"/>
-              </a:rPr>
-              <a:t>Oben in der Liste das Feld </a:t>
-            </a:r>
-            <a:r>
-              <a:rPr sz="1700" b="1">
-                <a:solidFill>
-                  <a:srgbClr val="111111"/>
-                </a:solidFill>
-                <a:latin typeface="Calibri"/>
-              </a:rPr>
-              <a:t>Status</a:t>
-            </a:r>
-            <a:r>
-              <a:rPr sz="1700" b="0">
-                <a:solidFill>
-                  <a:srgbClr val="111111"/>
-                </a:solidFill>
-                <a:latin typeface="Calibri"/>
-              </a:rPr>
-              <a:t> öffnen. Der Filter gilt in der Übersicht und nach der Schulung.</a:t>
-            </a:r>
-          </a:p>
-          <a:p>
-            <a:pPr algn="l">
-              <a:spcAft>
-                <a:spcPts val="1019"/>
-              </a:spcAft>
-            </a:pPr>
-            <a:r>
-              <a:rPr sz="1700" b="1">
-                <a:solidFill>
-                  <a:srgbClr val="111111"/>
-                </a:solidFill>
-                <a:latin typeface="Calibri"/>
-              </a:rPr>
-              <a:t>Keine Reaktion</a:t>
-            </a:r>
-            <a:r>
-              <a:rPr sz="1700" b="0">
-                <a:solidFill>
-                  <a:srgbClr val="111111"/>
-                </a:solidFill>
-                <a:latin typeface="Calibri"/>
-              </a:rPr>
-              <a:t> zeigt Gebuchte, die auf die Erinnerungen nicht reagiert haben. Ihr Platz ist wieder frei.</a:t>
+              <a:rPr sz="1600" b="0">
+                <a:solidFill>
+                  <a:srgbClr val="5F6368"/>
+                </a:solidFill>
+                <a:latin typeface="Calibri"/>
+              </a:rPr>
+              <a:t>Ist ein kommender Termin ausgebucht, schreibt ihr mit einem Klick alle Bewerber dieser Ausschreibung ohne Termin an. Sie bekommen eine WhatsApp mit dem Link zur Terminauswahl und buchen sich selbst in einen anderen Termin.</a:t>
             </a:r>
           </a:p>
         </p:txBody>
@@ -5277,8 +5157,8 @@
         </p:nvSpPr>
         <p:spPr>
           <a:xfrm>
-            <a:off x="685800" y="5394960"/>
-            <a:ext cx="3291840" cy="822960"/>
+            <a:off x="685800" y="2514600"/>
+            <a:ext cx="5212080" cy="2880360"/>
           </a:xfrm>
           <a:prstGeom prst="rect">
             <a:avLst/>
@@ -5293,50 +5173,205 @@
           <a:p>
             <a:pPr algn="l">
               <a:spcAft>
-                <a:spcPts val="1019"/>
+                <a:spcPts val="1080"/>
               </a:spcAft>
             </a:pPr>
             <a:r>
-              <a:rPr sz="1700" b="1">
-                <a:solidFill>
-                  <a:srgbClr val="1273DE"/>
-                </a:solidFill>
-                <a:latin typeface="Calibri"/>
-              </a:rPr>
-              <a:t>Praktisch zum Nachtelefonieren vor der Schulung.</a:t>
-            </a:r>
-          </a:p>
-        </p:txBody>
-      </p:sp>
-      <p:pic>
-        <p:nvPicPr>
-          <p:cNvPr id="10" name="Picture 9" descr="E_statusfilter.png"/>
-          <p:cNvPicPr>
-            <a:picLocks noChangeAspect="1"/>
-          </p:cNvPicPr>
-          <p:nvPr/>
-        </p:nvPicPr>
-        <p:blipFill>
-          <a:blip r:embed="rId2"/>
-          <a:stretch>
-            <a:fillRect/>
-          </a:stretch>
-        </p:blipFill>
-        <p:spPr>
-          <a:xfrm>
-            <a:off x="4160520" y="1902487"/>
-            <a:ext cx="7360920" cy="4205169"/>
-          </a:xfrm>
-          <a:prstGeom prst="rect">
-            <a:avLst/>
-          </a:prstGeom>
-          <a:ln w="9525">
-            <a:solidFill>
-              <a:srgbClr val="B8BCC4"/>
-            </a:solidFill>
-          </a:ln>
-        </p:spPr>
-      </p:pic>
+              <a:rPr sz="1800" b="0">
+                <a:solidFill>
+                  <a:srgbClr val="111111"/>
+                </a:solidFill>
+                <a:latin typeface="Calibri"/>
+              </a:rPr>
+              <a:t>1. </a:t>
+            </a:r>
+            <a:r>
+              <a:rPr sz="1800" b="1">
+                <a:solidFill>
+                  <a:srgbClr val="111111"/>
+                </a:solidFill>
+                <a:latin typeface="Calibri"/>
+              </a:rPr>
+              <a:t>Statistik</a:t>
+            </a:r>
+            <a:r>
+              <a:rPr sz="1800" b="0">
+                <a:solidFill>
+                  <a:srgbClr val="111111"/>
+                </a:solidFill>
+                <a:latin typeface="Calibri"/>
+              </a:rPr>
+              <a:t> öffnen, Filiale wählen, nach unten zur Tabelle </a:t>
+            </a:r>
+            <a:r>
+              <a:rPr sz="1800" b="1">
+                <a:solidFill>
+                  <a:srgbClr val="111111"/>
+                </a:solidFill>
+                <a:latin typeface="Calibri"/>
+              </a:rPr>
+              <a:t>„Schulungstermine“</a:t>
+            </a:r>
+            <a:r>
+              <a:rPr sz="1800" b="0">
+                <a:solidFill>
+                  <a:srgbClr val="111111"/>
+                </a:solidFill>
+                <a:latin typeface="Calibri"/>
+              </a:rPr>
+              <a:t> scrollen.</a:t>
+            </a:r>
+          </a:p>
+          <a:p>
+            <a:pPr algn="l">
+              <a:spcAft>
+                <a:spcPts val="1080"/>
+              </a:spcAft>
+            </a:pPr>
+            <a:r>
+              <a:rPr sz="1800" b="0">
+                <a:solidFill>
+                  <a:srgbClr val="111111"/>
+                </a:solidFill>
+                <a:latin typeface="Calibri"/>
+              </a:rPr>
+              <a:t>2. Am vollen Termin steht in der Spalte Ausschreibung das Badge </a:t>
+            </a:r>
+            <a:r>
+              <a:rPr sz="1800" b="1">
+                <a:solidFill>
+                  <a:srgbClr val="111111"/>
+                </a:solidFill>
+                <a:latin typeface="Calibri"/>
+              </a:rPr>
+              <a:t>„Ausgebucht“</a:t>
+            </a:r>
+            <a:r>
+              <a:rPr sz="1800" b="0">
+                <a:solidFill>
+                  <a:srgbClr val="111111"/>
+                </a:solidFill>
+                <a:latin typeface="Calibri"/>
+              </a:rPr>
+              <a:t> und daneben die Pille </a:t>
+            </a:r>
+            <a:r>
+              <a:rPr sz="1800" b="1">
+                <a:solidFill>
+                  <a:srgbClr val="111111"/>
+                </a:solidFill>
+                <a:latin typeface="Calibri"/>
+              </a:rPr>
+              <a:t>„N ohne Termin“</a:t>
+            </a:r>
+            <a:r>
+              <a:rPr sz="1800" b="0">
+                <a:solidFill>
+                  <a:srgbClr val="111111"/>
+                </a:solidFill>
+                <a:latin typeface="Calibri"/>
+              </a:rPr>
+              <a:t>. Auf die Pille klicken.</a:t>
+            </a:r>
+          </a:p>
+        </p:txBody>
+      </p:sp>
+      <p:sp>
+        <p:nvSpPr>
+          <p:cNvPr id="10" name="TextBox 9"/>
+          <p:cNvSpPr txBox="1"/>
+          <p:nvPr/>
+        </p:nvSpPr>
+        <p:spPr>
+          <a:xfrm>
+            <a:off x="6263640" y="2514600"/>
+            <a:ext cx="5212080" cy="2880360"/>
+          </a:xfrm>
+          <a:prstGeom prst="rect">
+            <a:avLst/>
+          </a:prstGeom>
+          <a:noFill/>
+        </p:spPr>
+        <p:txBody>
+          <a:bodyPr wrap="square" anchor="t" lIns="45720" rIns="45720">
+            <a:spAutoFit/>
+          </a:bodyPr>
+          <a:lstStyle/>
+          <a:p>
+            <a:pPr algn="l">
+              <a:spcAft>
+                <a:spcPts val="1080"/>
+              </a:spcAft>
+            </a:pPr>
+            <a:r>
+              <a:rPr sz="1800" b="0">
+                <a:solidFill>
+                  <a:srgbClr val="111111"/>
+                </a:solidFill>
+                <a:latin typeface="Calibri"/>
+              </a:rPr>
+              <a:t>3. Oben im Fenster steht der Anlass: welcher Termin voll ist und wie viele weitere Termine mit freien Plätzen es an dieser Stelle gibt. </a:t>
+            </a:r>
+            <a:r>
+              <a:rPr sz="1800" b="1">
+                <a:solidFill>
+                  <a:srgbClr val="111111"/>
+                </a:solidFill>
+                <a:latin typeface="Calibri"/>
+              </a:rPr>
+              <a:t>Ist die Karte rot, gibt es keine Alternative.</a:t>
+            </a:r>
+            <a:r>
+              <a:rPr sz="1800" b="0">
+                <a:solidFill>
+                  <a:srgbClr val="111111"/>
+                </a:solidFill>
+                <a:latin typeface="Calibri"/>
+              </a:rPr>
+              <a:t> Dann erst einen neuen Termin anlegen.</a:t>
+            </a:r>
+          </a:p>
+        </p:txBody>
+      </p:sp>
+      <p:sp>
+        <p:nvSpPr>
+          <p:cNvPr id="11" name="TextBox 10"/>
+          <p:cNvSpPr txBox="1"/>
+          <p:nvPr/>
+        </p:nvSpPr>
+        <p:spPr>
+          <a:xfrm>
+            <a:off x="685800" y="5486400"/>
+            <a:ext cx="10789920" cy="731520"/>
+          </a:xfrm>
+          <a:prstGeom prst="rect">
+            <a:avLst/>
+          </a:prstGeom>
+          <a:noFill/>
+        </p:spPr>
+        <p:txBody>
+          <a:bodyPr wrap="square" anchor="t" lIns="45720" rIns="45720">
+            <a:spAutoFit/>
+          </a:bodyPr>
+          <a:lstStyle/>
+          <a:p>
+            <a:pPr algn="l">
+              <a:spcAft>
+                <a:spcPts val="960"/>
+              </a:spcAft>
+            </a:pPr>
+            <a:r>
+              <a:rPr sz="1600" b="0">
+                <a:solidFill>
+                  <a:srgbClr val="5F6368"/>
+                </a:solidFill>
+                <a:latin typeface="Calibri"/>
+              </a:rPr>
+              <a:t>Die Pille erscheint nur bei Platzzahl, voll belegt, künftigem Termin und hinterlegter Ausschreibung. Fehlt die Ausschreibung, steht nur das Badge mit „keine Ausschreibung“.</a:t>
+            </a:r>
+          </a:p>
+        </p:txBody>
+      </p:sp>
     </p:spTree>
   </p:cSld>
   <p:clrMapOvr>
@@ -5432,7 +5467,7 @@
                 </a:solidFill>
                 <a:latin typeface="Calibri"/>
               </a:rPr>
-              <a:t>WENN EINE SCHULUNG VOLL IST</a:t>
+              <a:t>WENN EINE SCHULUNG VOLL IST · SCHRITT 2</a:t>
             </a:r>
           </a:p>
         </p:txBody>
@@ -5471,7 +5506,7 @@
                 </a:solidFill>
                 <a:latin typeface="Calibri"/>
               </a:rPr>
-              <a:t>Bewerber ohne Termin auf freie Termine hinweisen</a:t>
+              <a:t>Empfänger prüfen und senden</a:t>
             </a:r>
           </a:p>
         </p:txBody>
@@ -5606,7 +5641,7 @@
         <p:spPr>
           <a:xfrm>
             <a:off x="685800" y="1773936"/>
-            <a:ext cx="5120640" cy="4023360"/>
+            <a:ext cx="5212080" cy="3621024"/>
           </a:xfrm>
           <a:prstGeom prst="rect">
             <a:avLst/>
@@ -5621,121 +5656,69 @@
           <a:p>
             <a:pPr algn="l">
               <a:spcAft>
-                <a:spcPts val="1170"/>
+                <a:spcPts val="1080"/>
               </a:spcAft>
             </a:pPr>
             <a:r>
-              <a:rPr sz="1950" b="0">
+              <a:rPr sz="1800" b="0">
                 <a:solidFill>
                   <a:srgbClr val="111111"/>
                 </a:solidFill>
                 <a:latin typeface="Calibri"/>
               </a:rPr>
-              <a:t>1. </a:t>
-            </a:r>
-            <a:r>
-              <a:rPr sz="1950" b="1">
+              <a:t>4. Die Liste zeigt die Bewerber. Jede angehakte Zeile trägt den Chip </a:t>
+            </a:r>
+            <a:r>
+              <a:rPr sz="1800" b="1">
                 <a:solidFill>
                   <a:srgbClr val="111111"/>
                 </a:solidFill>
                 <a:latin typeface="Calibri"/>
               </a:rPr>
-              <a:t>Statistik</a:t>
-            </a:r>
-            <a:r>
-              <a:rPr sz="1950" b="0">
+              <a:t>„bekommt: Termine ansehen“</a:t>
+            </a:r>
+            <a:r>
+              <a:rPr sz="1800" b="0">
                 <a:solidFill>
                   <a:srgbClr val="111111"/>
                 </a:solidFill>
                 <a:latin typeface="Calibri"/>
               </a:rPr>
-              <a:t> öffnen, Filiale wählen, zu </a:t>
-            </a:r>
-            <a:r>
-              <a:rPr sz="1950" b="1">
-                <a:solidFill>
-                  <a:srgbClr val="111111"/>
-                </a:solidFill>
-                <a:latin typeface="Calibri"/>
-              </a:rPr>
-              <a:t>„Schulungstermine“</a:t>
-            </a:r>
-            <a:r>
-              <a:rPr sz="1950" b="0">
-                <a:solidFill>
-                  <a:srgbClr val="111111"/>
-                </a:solidFill>
-                <a:latin typeface="Calibri"/>
-              </a:rPr>
-              <a:t> scrollen.</a:t>
+              <a:t>. Wer nicht angeschrieben werden soll: Haken raus. Graue Zeilen sind gesperrt, der Grund steht daneben.</a:t>
             </a:r>
           </a:p>
           <a:p>
             <a:pPr algn="l">
               <a:spcAft>
-                <a:spcPts val="1170"/>
+                <a:spcPts val="1080"/>
               </a:spcAft>
             </a:pPr>
             <a:r>
-              <a:rPr sz="1950" b="0">
+              <a:rPr sz="1800" b="0">
                 <a:solidFill>
                   <a:srgbClr val="111111"/>
                 </a:solidFill>
                 <a:latin typeface="Calibri"/>
               </a:rPr>
-              <a:t>2. Am vollen Termin auf die Pille </a:t>
-            </a:r>
-            <a:r>
-              <a:rPr sz="1950" b="1">
+              <a:t>5. Unten steht die Nachricht so, wie der Bewerber sie liest, mit „Anna“ als Beispielname. Beim Versand steht dort der echte Vorname. Über </a:t>
+            </a:r>
+            <a:r>
+              <a:rPr sz="1800" b="1">
                 <a:solidFill>
                   <a:srgbClr val="111111"/>
                 </a:solidFill>
                 <a:latin typeface="Calibri"/>
               </a:rPr>
-              <a:t>„N ohne Termin“</a:t>
-            </a:r>
-            <a:r>
-              <a:rPr sz="1950" b="0">
+              <a:t>„Vorlage ändern“</a:t>
+            </a:r>
+            <a:r>
+              <a:rPr sz="1800" b="0">
                 <a:solidFill>
                   <a:srgbClr val="111111"/>
                 </a:solidFill>
                 <a:latin typeface="Calibri"/>
               </a:rPr>
-              <a:t> klicken.</a:t>
-            </a:r>
-          </a:p>
-          <a:p>
-            <a:pPr algn="l">
-              <a:spcAft>
-                <a:spcPts val="1170"/>
-              </a:spcAft>
-            </a:pPr>
-            <a:r>
-              <a:rPr sz="1950" b="0">
-                <a:solidFill>
-                  <a:srgbClr val="111111"/>
-                </a:solidFill>
-                <a:latin typeface="Calibri"/>
-              </a:rPr>
-              <a:t>3. Oben die </a:t>
-            </a:r>
-            <a:r>
-              <a:rPr sz="1950" b="1">
-                <a:solidFill>
-                  <a:srgbClr val="111111"/>
-                </a:solidFill>
-                <a:latin typeface="Calibri"/>
-              </a:rPr>
-              <a:t>Anlass-Karte</a:t>
-            </a:r>
-            <a:r>
-              <a:rPr sz="1950" b="0">
-                <a:solidFill>
-                  <a:srgbClr val="111111"/>
-                </a:solidFill>
-                <a:latin typeface="Calibri"/>
-              </a:rPr>
-              <a:t> lesen. Ist sie rot, gibt es keinen freien Termin: erst einen anlegen.</a:t>
+              <a:t> wählt ihr eine andere Vorlage.</a:t>
             </a:r>
           </a:p>
         </p:txBody>
@@ -5748,8 +5731,8 @@
         </p:nvSpPr>
         <p:spPr>
           <a:xfrm>
-            <a:off x="6309360" y="1773936"/>
-            <a:ext cx="5120640" cy="2926080"/>
+            <a:off x="6263640" y="1773936"/>
+            <a:ext cx="5212080" cy="3621024"/>
           </a:xfrm>
           <a:prstGeom prst="rect">
             <a:avLst/>
@@ -5764,51 +5747,35 @@
           <a:p>
             <a:pPr algn="l">
               <a:spcAft>
-                <a:spcPts val="1170"/>
+                <a:spcPts val="1080"/>
               </a:spcAft>
             </a:pPr>
             <a:r>
-              <a:rPr sz="1950" b="0">
+              <a:rPr sz="1800" b="0">
                 <a:solidFill>
                   <a:srgbClr val="111111"/>
                 </a:solidFill>
                 <a:latin typeface="Calibri"/>
               </a:rPr>
-              <a:t>4. Empfänger prüfen, wer nicht soll: Haken raus.</a:t>
-            </a:r>
-          </a:p>
-          <a:p>
-            <a:pPr algn="l">
-              <a:spcAft>
-                <a:spcPts val="1170"/>
-              </a:spcAft>
-            </a:pPr>
-            <a:r>
-              <a:rPr sz="1950" b="0">
+              <a:t>6. Auf </a:t>
+            </a:r>
+            <a:r>
+              <a:rPr sz="1800" b="1">
                 <a:solidFill>
                   <a:srgbClr val="111111"/>
                 </a:solidFill>
                 <a:latin typeface="Calibri"/>
               </a:rPr>
-              <a:t>5. Auf </a:t>
-            </a:r>
-            <a:r>
-              <a:rPr sz="1950" b="1">
+              <a:t>„WhatsApp an N Personen senden“</a:t>
+            </a:r>
+            <a:r>
+              <a:rPr sz="1800" b="0">
                 <a:solidFill>
                   <a:srgbClr val="111111"/>
                 </a:solidFill>
                 <a:latin typeface="Calibri"/>
               </a:rPr>
-              <a:t>„WhatsApp an N Personen senden“</a:t>
-            </a:r>
-            <a:r>
-              <a:rPr sz="1950" b="0">
-                <a:solidFill>
-                  <a:srgbClr val="111111"/>
-                </a:solidFill>
-                <a:latin typeface="Calibri"/>
-              </a:rPr>
-              <a:t> klicken und bestätigen.</a:t>
+              <a:t> klicken und die Nachfrage bestätigen. Der Fortschritt läuft im Fenster mit.</a:t>
             </a:r>
           </a:p>
         </p:txBody>
@@ -5821,47 +5788,8 @@
         </p:nvSpPr>
         <p:spPr>
           <a:xfrm>
-            <a:off x="6309360" y="4206240"/>
-            <a:ext cx="5120640" cy="3657600"/>
-          </a:xfrm>
-          <a:prstGeom prst="rect">
-            <a:avLst/>
-          </a:prstGeom>
-          <a:noFill/>
-        </p:spPr>
-        <p:txBody>
-          <a:bodyPr wrap="square" anchor="t" lIns="45720" rIns="45720">
-            <a:spAutoFit/>
-          </a:bodyPr>
-          <a:lstStyle/>
-          <a:p>
-            <a:pPr algn="l">
-              <a:spcAft>
-                <a:spcPts val="1140"/>
-              </a:spcAft>
-            </a:pPr>
-            <a:r>
-              <a:rPr sz="1900" b="1">
-                <a:solidFill>
-                  <a:srgbClr val="1273DE"/>
-                </a:solidFill>
-                <a:latin typeface="Calibri"/>
-              </a:rPr>
-              <a:t>Die Bewerber buchen sich selbst in einen freien Termin.</a:t>
-            </a:r>
-          </a:p>
-        </p:txBody>
-      </p:sp>
-      <p:sp>
-        <p:nvSpPr>
-          <p:cNvPr id="11" name="TextBox 10"/>
-          <p:cNvSpPr txBox="1"/>
-          <p:nvPr/>
-        </p:nvSpPr>
-        <p:spPr>
-          <a:xfrm>
-            <a:off x="685800" y="5577840"/>
-            <a:ext cx="10789920" cy="640080"/>
+            <a:off x="685800" y="5486400"/>
+            <a:ext cx="10789920" cy="731520"/>
           </a:xfrm>
           <a:prstGeom prst="rect">
             <a:avLst/>
@@ -5880,13 +5808,13 @@
               </a:spcAft>
             </a:pPr>
             <a:r>
-              <a:rPr sz="1600" b="0">
-                <a:solidFill>
-                  <a:srgbClr val="5F6368"/>
-                </a:solidFill>
-                <a:latin typeface="Calibri"/>
-              </a:rPr>
-              <a:t>Die Pille erscheint nur bei voller Platzzahl, künftigem Termin und hinterlegter Ausschreibung.</a:t>
+              <a:rPr sz="1600" b="1">
+                <a:solidFill>
+                  <a:srgbClr val="1273DE"/>
+                </a:solidFill>
+                <a:latin typeface="Calibri"/>
+              </a:rPr>
+              <a:t>Die Bewerber buchen sich danach selbst in einen freien Termin.</a:t>
             </a:r>
           </a:p>
         </p:txBody>
@@ -5986,7 +5914,7 @@
                 </a:solidFill>
                 <a:latin typeface="Calibri"/>
               </a:rPr>
-              <a:t>GUT ZU WISSEN</a:t>
+              <a:t>NEU · NACH DER SCHULUNG</a:t>
             </a:r>
           </a:p>
         </p:txBody>
@@ -6025,7 +5953,7 @@
                 </a:solidFill>
                 <a:latin typeface="Calibri"/>
               </a:rPr>
-              <a:t>Regeln auf einen Blick</a:t>
+              <a:t>Vertragsdaten eintragen, auch zu zweit</a:t>
             </a:r>
           </a:p>
         </p:txBody>
@@ -6151,6 +6079,495 @@
           </a:p>
         </p:txBody>
       </p:sp>
+      <p:sp>
+        <p:nvSpPr>
+          <p:cNvPr id="8" name="TextBox 7"/>
+          <p:cNvSpPr txBox="1"/>
+          <p:nvPr/>
+        </p:nvSpPr>
+        <p:spPr>
+          <a:xfrm>
+            <a:off x="685800" y="1773936"/>
+            <a:ext cx="3291840" cy="3657600"/>
+          </a:xfrm>
+          <a:prstGeom prst="rect">
+            <a:avLst/>
+          </a:prstGeom>
+          <a:noFill/>
+        </p:spPr>
+        <p:txBody>
+          <a:bodyPr wrap="square" anchor="t" lIns="45720" rIns="45720">
+            <a:spAutoFit/>
+          </a:bodyPr>
+          <a:lstStyle/>
+          <a:p>
+            <a:pPr algn="l">
+              <a:spcAft>
+                <a:spcPts val="1019"/>
+              </a:spcAft>
+            </a:pPr>
+            <a:r>
+              <a:rPr sz="1700" b="0">
+                <a:solidFill>
+                  <a:srgbClr val="111111"/>
+                </a:solidFill>
+                <a:latin typeface="Calibri"/>
+              </a:rPr>
+              <a:t>1. Den Termin öffnen, Reiter </a:t>
+            </a:r>
+            <a:r>
+              <a:rPr sz="1700" b="1">
+                <a:solidFill>
+                  <a:srgbClr val="111111"/>
+                </a:solidFill>
+                <a:latin typeface="Calibri"/>
+              </a:rPr>
+              <a:t>„Nach der Schulung“</a:t>
+            </a:r>
+            <a:r>
+              <a:rPr sz="1700" b="0">
+                <a:solidFill>
+                  <a:srgbClr val="111111"/>
+                </a:solidFill>
+                <a:latin typeface="Calibri"/>
+              </a:rPr>
+              <a:t>.</a:t>
+            </a:r>
+          </a:p>
+          <a:p>
+            <a:pPr algn="l">
+              <a:spcAft>
+                <a:spcPts val="1019"/>
+              </a:spcAft>
+            </a:pPr>
+            <a:r>
+              <a:rPr sz="1700" b="0">
+                <a:solidFill>
+                  <a:srgbClr val="111111"/>
+                </a:solidFill>
+                <a:latin typeface="Calibri"/>
+              </a:rPr>
+              <a:t>2. </a:t>
+            </a:r>
+            <a:r>
+              <a:rPr sz="1700" b="1">
+                <a:solidFill>
+                  <a:srgbClr val="111111"/>
+                </a:solidFill>
+                <a:latin typeface="Calibri"/>
+              </a:rPr>
+              <a:t>Zuschlag</a:t>
+            </a:r>
+            <a:r>
+              <a:rPr sz="1700" b="0">
+                <a:solidFill>
+                  <a:srgbClr val="111111"/>
+                </a:solidFill>
+                <a:latin typeface="Calibri"/>
+              </a:rPr>
+              <a:t>, </a:t>
+            </a:r>
+            <a:r>
+              <a:rPr sz="1700" b="1">
+                <a:solidFill>
+                  <a:srgbClr val="111111"/>
+                </a:solidFill>
+                <a:latin typeface="Calibri"/>
+              </a:rPr>
+              <a:t>Vertragsbeginn</a:t>
+            </a:r>
+            <a:r>
+              <a:rPr sz="1700" b="0">
+                <a:solidFill>
+                  <a:srgbClr val="111111"/>
+                </a:solidFill>
+                <a:latin typeface="Calibri"/>
+              </a:rPr>
+              <a:t> und bei Bedarf </a:t>
+            </a:r>
+            <a:r>
+              <a:rPr sz="1700" b="1">
+                <a:solidFill>
+                  <a:srgbClr val="111111"/>
+                </a:solidFill>
+                <a:latin typeface="Calibri"/>
+              </a:rPr>
+              <a:t>Vertragsende</a:t>
+            </a:r>
+            <a:r>
+              <a:rPr sz="1700" b="0">
+                <a:solidFill>
+                  <a:srgbClr val="111111"/>
+                </a:solidFill>
+                <a:latin typeface="Calibri"/>
+              </a:rPr>
+              <a:t> eintragen. Ohne Ende rechnet das System es aus.</a:t>
+            </a:r>
+          </a:p>
+          <a:p>
+            <a:pPr algn="l">
+              <a:spcAft>
+                <a:spcPts val="1019"/>
+              </a:spcAft>
+            </a:pPr>
+            <a:r>
+              <a:rPr sz="1700" b="0">
+                <a:solidFill>
+                  <a:srgbClr val="111111"/>
+                </a:solidFill>
+                <a:latin typeface="Calibri"/>
+              </a:rPr>
+              <a:t>3. Zum Schluss die Verträge über den </a:t>
+            </a:r>
+            <a:r>
+              <a:rPr sz="1700" b="1">
+                <a:solidFill>
+                  <a:srgbClr val="111111"/>
+                </a:solidFill>
+                <a:latin typeface="Calibri"/>
+              </a:rPr>
+              <a:t>Sammelversand</a:t>
+            </a:r>
+            <a:r>
+              <a:rPr sz="1700" b="0">
+                <a:solidFill>
+                  <a:srgbClr val="111111"/>
+                </a:solidFill>
+                <a:latin typeface="Calibri"/>
+              </a:rPr>
+              <a:t> schicken.</a:t>
+            </a:r>
+          </a:p>
+        </p:txBody>
+      </p:sp>
+      <p:sp>
+        <p:nvSpPr>
+          <p:cNvPr id="9" name="TextBox 8"/>
+          <p:cNvSpPr txBox="1"/>
+          <p:nvPr/>
+        </p:nvSpPr>
+        <p:spPr>
+          <a:xfrm>
+            <a:off x="685800" y="5257800"/>
+            <a:ext cx="3291840" cy="1005840"/>
+          </a:xfrm>
+          <a:prstGeom prst="rect">
+            <a:avLst/>
+          </a:prstGeom>
+          <a:noFill/>
+        </p:spPr>
+        <p:txBody>
+          <a:bodyPr wrap="square" anchor="t" lIns="45720" rIns="45720">
+            <a:spAutoFit/>
+          </a:bodyPr>
+          <a:lstStyle/>
+          <a:p>
+            <a:pPr algn="l">
+              <a:spcAft>
+                <a:spcPts val="960"/>
+              </a:spcAft>
+            </a:pPr>
+            <a:r>
+              <a:rPr sz="1600" b="1">
+                <a:solidFill>
+                  <a:srgbClr val="1273DE"/>
+                </a:solidFill>
+                <a:latin typeface="Calibri"/>
+              </a:rPr>
+              <a:t>Jede Eingabe ist sofort gespeichert. Zwei Laptops sehen denselben Stand.</a:t>
+            </a:r>
+          </a:p>
+        </p:txBody>
+      </p:sp>
+      <p:pic>
+        <p:nvPicPr>
+          <p:cNvPr id="10" name="Picture 9" descr="D_nach_der_schulung.png"/>
+          <p:cNvPicPr>
+            <a:picLocks noChangeAspect="1"/>
+          </p:cNvPicPr>
+          <p:nvPr/>
+        </p:nvPicPr>
+        <p:blipFill>
+          <a:blip r:embed="rId2"/>
+          <a:stretch>
+            <a:fillRect/>
+          </a:stretch>
+        </p:blipFill>
+        <p:spPr>
+          <a:xfrm>
+            <a:off x="4160520" y="2178763"/>
+            <a:ext cx="7360920" cy="3597753"/>
+          </a:xfrm>
+          <a:prstGeom prst="rect">
+            <a:avLst/>
+          </a:prstGeom>
+          <a:ln w="9525">
+            <a:solidFill>
+              <a:srgbClr val="B8BCC4"/>
+            </a:solidFill>
+          </a:ln>
+        </p:spPr>
+      </p:pic>
+    </p:spTree>
+  </p:cSld>
+  <p:clrMapOvr>
+    <a:masterClrMapping/>
+  </p:clrMapOvr>
+</p:sld>
+</file>
+
+<file path=ppt/slides/slide8.xml><?xml version="1.0" encoding="utf-8"?>
+<p:sld xmlns:a="http://schemas.openxmlformats.org/drawingml/2006/main" xmlns:p="http://schemas.openxmlformats.org/presentationml/2006/main" xmlns:r="http://schemas.openxmlformats.org/officeDocument/2006/relationships">
+  <p:cSld>
+    <p:spTree>
+      <p:nvGrpSpPr>
+        <p:cNvPr id="1" name=""/>
+        <p:cNvGrpSpPr/>
+        <p:nvPr/>
+      </p:nvGrpSpPr>
+      <p:grpSpPr/>
+      <p:sp>
+        <p:nvSpPr>
+          <p:cNvPr id="2" name="Rectangle 1"/>
+          <p:cNvSpPr/>
+          <p:nvPr/>
+        </p:nvSpPr>
+        <p:spPr>
+          <a:xfrm>
+            <a:off x="0" y="0"/>
+            <a:ext cx="155448" cy="6858000"/>
+          </a:xfrm>
+          <a:prstGeom prst="rect">
+            <a:avLst/>
+          </a:prstGeom>
+          <a:solidFill>
+            <a:srgbClr val="1273DE"/>
+          </a:solidFill>
+          <a:ln>
+            <a:noFill/>
+          </a:ln>
+        </p:spPr>
+        <p:style>
+          <a:lnRef idx="1">
+            <a:schemeClr val="accent1"/>
+          </a:lnRef>
+          <a:fillRef idx="3">
+            <a:schemeClr val="accent1"/>
+          </a:fillRef>
+          <a:effectRef idx="2">
+            <a:schemeClr val="accent1"/>
+          </a:effectRef>
+          <a:fontRef idx="minor">
+            <a:schemeClr val="lt1"/>
+          </a:fontRef>
+        </p:style>
+        <p:txBody>
+          <a:bodyPr rtlCol="0" anchor="ctr"/>
+          <a:lstStyle/>
+          <a:p>
+            <a:pPr algn="ctr"/>
+          </a:p>
+        </p:txBody>
+      </p:sp>
+      <p:sp>
+        <p:nvSpPr>
+          <p:cNvPr id="3" name="TextBox 2"/>
+          <p:cNvSpPr txBox="1"/>
+          <p:nvPr/>
+        </p:nvSpPr>
+        <p:spPr>
+          <a:xfrm>
+            <a:off x="612648" y="329184"/>
+            <a:ext cx="10479024" cy="274320"/>
+          </a:xfrm>
+          <a:prstGeom prst="rect">
+            <a:avLst/>
+          </a:prstGeom>
+          <a:noFill/>
+        </p:spPr>
+        <p:txBody>
+          <a:bodyPr wrap="square" anchor="t" lIns="45720" rIns="45720">
+            <a:spAutoFit/>
+          </a:bodyPr>
+          <a:lstStyle/>
+          <a:p>
+            <a:pPr algn="l">
+              <a:spcAft>
+                <a:spcPts val="719"/>
+              </a:spcAft>
+            </a:pPr>
+            <a:r>
+              <a:rPr sz="1200" b="1">
+                <a:solidFill>
+                  <a:srgbClr val="1273DE"/>
+                </a:solidFill>
+                <a:latin typeface="Calibri"/>
+              </a:rPr>
+              <a:t>GUT ZU WISSEN · VERSCHIEBEN UND NACHBEREITUNG</a:t>
+            </a:r>
+          </a:p>
+        </p:txBody>
+      </p:sp>
+      <p:sp>
+        <p:nvSpPr>
+          <p:cNvPr id="4" name="TextBox 3"/>
+          <p:cNvSpPr txBox="1"/>
+          <p:nvPr/>
+        </p:nvSpPr>
+        <p:spPr>
+          <a:xfrm>
+            <a:off x="612648" y="731520"/>
+            <a:ext cx="10936224" cy="640080"/>
+          </a:xfrm>
+          <a:prstGeom prst="rect">
+            <a:avLst/>
+          </a:prstGeom>
+          <a:noFill/>
+        </p:spPr>
+        <p:txBody>
+          <a:bodyPr wrap="square" anchor="t" lIns="45720" rIns="45720">
+            <a:spAutoFit/>
+          </a:bodyPr>
+          <a:lstStyle/>
+          <a:p>
+            <a:pPr algn="l">
+              <a:spcAft>
+                <a:spcPts val="1709"/>
+              </a:spcAft>
+            </a:pPr>
+            <a:r>
+              <a:rPr sz="2850" b="1">
+                <a:solidFill>
+                  <a:srgbClr val="111111"/>
+                </a:solidFill>
+                <a:latin typeface="Calibri"/>
+              </a:rPr>
+              <a:t>Regeln auf einen Blick</a:t>
+            </a:r>
+          </a:p>
+        </p:txBody>
+      </p:sp>
+      <p:sp>
+        <p:nvSpPr>
+          <p:cNvPr id="5" name="Rectangle 4"/>
+          <p:cNvSpPr/>
+          <p:nvPr/>
+        </p:nvSpPr>
+        <p:spPr>
+          <a:xfrm>
+            <a:off x="512064" y="1435608"/>
+            <a:ext cx="11128248" cy="9144"/>
+          </a:xfrm>
+          <a:prstGeom prst="rect">
+            <a:avLst/>
+          </a:prstGeom>
+          <a:solidFill>
+            <a:srgbClr val="B8BCC4"/>
+          </a:solidFill>
+          <a:ln>
+            <a:noFill/>
+          </a:ln>
+        </p:spPr>
+        <p:style>
+          <a:lnRef idx="1">
+            <a:schemeClr val="accent1"/>
+          </a:lnRef>
+          <a:fillRef idx="3">
+            <a:schemeClr val="accent1"/>
+          </a:fillRef>
+          <a:effectRef idx="2">
+            <a:schemeClr val="accent1"/>
+          </a:effectRef>
+          <a:fontRef idx="minor">
+            <a:schemeClr val="lt1"/>
+          </a:fontRef>
+        </p:style>
+        <p:txBody>
+          <a:bodyPr rtlCol="0" anchor="ctr"/>
+          <a:lstStyle/>
+          <a:p>
+            <a:pPr algn="ctr"/>
+          </a:p>
+        </p:txBody>
+      </p:sp>
+      <p:sp>
+        <p:nvSpPr>
+          <p:cNvPr id="6" name="TextBox 5"/>
+          <p:cNvSpPr txBox="1"/>
+          <p:nvPr/>
+        </p:nvSpPr>
+        <p:spPr>
+          <a:xfrm>
+            <a:off x="612648" y="6419088"/>
+            <a:ext cx="6190488" cy="274320"/>
+          </a:xfrm>
+          <a:prstGeom prst="rect">
+            <a:avLst/>
+          </a:prstGeom>
+          <a:noFill/>
+        </p:spPr>
+        <p:txBody>
+          <a:bodyPr wrap="square" anchor="t" lIns="45720" rIns="45720">
+            <a:spAutoFit/>
+          </a:bodyPr>
+          <a:lstStyle/>
+          <a:p>
+            <a:pPr algn="l">
+              <a:spcAft>
+                <a:spcPts val="630"/>
+              </a:spcAft>
+            </a:pPr>
+            <a:r>
+              <a:rPr sz="1050" b="0">
+                <a:solidFill>
+                  <a:srgbClr val="5F6368"/>
+                </a:solidFill>
+                <a:latin typeface="Calibri"/>
+              </a:rPr>
+              <a:t>RheinGedeck · Intern</a:t>
+            </a:r>
+          </a:p>
+        </p:txBody>
+      </p:sp>
+      <p:sp>
+        <p:nvSpPr>
+          <p:cNvPr id="7" name="TextBox 6"/>
+          <p:cNvSpPr txBox="1"/>
+          <p:nvPr/>
+        </p:nvSpPr>
+        <p:spPr>
+          <a:xfrm>
+            <a:off x="11009376" y="6419088"/>
+            <a:ext cx="530352" cy="274320"/>
+          </a:xfrm>
+          <a:prstGeom prst="rect">
+            <a:avLst/>
+          </a:prstGeom>
+          <a:noFill/>
+        </p:spPr>
+        <p:txBody>
+          <a:bodyPr wrap="square" anchor="t" lIns="45720" rIns="45720">
+            <a:spAutoFit/>
+          </a:bodyPr>
+          <a:lstStyle/>
+          <a:p>
+            <a:pPr algn="r">
+              <a:spcAft>
+                <a:spcPts val="630"/>
+              </a:spcAft>
+            </a:pPr>
+            <a:r>
+              <a:rPr sz="1050" b="0">
+                <a:solidFill>
+                  <a:srgbClr val="5F6368"/>
+                </a:solidFill>
+                <a:latin typeface="Calibri"/>
+              </a:rPr>
+              <a:t>08</a:t>
+            </a:r>
+          </a:p>
+        </p:txBody>
+      </p:sp>
       <p:graphicFrame>
         <p:nvGraphicFramePr>
           <p:cNvPr id="8" name="Table 7"/>
@@ -6160,8 +6577,8 @@
           <p:nvPr/>
         </p:nvGraphicFramePr>
         <p:xfrm>
-          <a:off x="685800" y="1783080"/>
-          <a:ext cx="10789920" cy="4389120"/>
+          <a:off x="685800" y="1737360"/>
+          <a:ext cx="10789920" cy="3291839"/>
         </p:xfrm>
         <a:graphic>
           <a:graphicData uri="http://schemas.openxmlformats.org/drawingml/2006/table">
@@ -6170,27 +6587,27 @@
                 <a:tableStyleId>{5C22544A-7EE6-4342-B048-85BDC9FD1C3A}</a:tableStyleId>
               </a:tblPr>
               <a:tblGrid>
-                <a:gridCol w="3108960"/>
-                <a:gridCol w="7680960"/>
+                <a:gridCol w="3017520"/>
+                <a:gridCol w="7772400"/>
               </a:tblGrid>
-              <a:tr h="627017">
+              <a:tr h="548639">
                 <a:tc>
                   <a:txBody>
                     <a:bodyPr/>
                     <a:lstStyle/>
                     <a:p>
                       <a:r>
-                        <a:rPr sz="1600" b="1">
+                        <a:rPr sz="1400" b="1">
                           <a:solidFill>
                             <a:srgbClr val="1273DE"/>
                           </a:solidFill>
                           <a:latin typeface="Calibri"/>
                         </a:rPr>
-                        <a:t>Verschieben: Termine</a:t>
+                        <a:t>Verschieben: welche Termine</a:t>
                       </a:r>
                     </a:p>
                   </a:txBody>
-                  <a:tcPr marL="109728">
+                  <a:tcPr marL="109728" marT="45720" marB="45720">
                     <a:solidFill>
                       <a:srgbClr val="F1F3F5"/>
                     </a:solidFill>
@@ -6202,31 +6619,31 @@
                     <a:lstStyle/>
                     <a:p>
                       <a:r>
-                        <a:rPr sz="1600" b="0">
+                        <a:rPr sz="1400" b="0">
                           <a:solidFill>
                             <a:srgbClr val="111111"/>
                           </a:solidFill>
                           <a:latin typeface="Calibri"/>
                         </a:rPr>
-                        <a:t>Nur aktive Termine derselben Stelle, die noch nicht zu Ende sind.</a:t>
+                        <a:t>Nur aktive Termine derselben Stelle (gleicher Ort), die noch nicht zu Ende sind. Ein laufender Termin geht also noch. Wer in eine andere Filiale soll, bucht über die Terminauswahl neu.</a:t>
                       </a:r>
                     </a:p>
                   </a:txBody>
-                  <a:tcPr marL="109728">
+                  <a:tcPr marL="109728" marT="45720" marB="45720">
                     <a:solidFill>
                       <a:srgbClr val="F1F3F5"/>
                     </a:solidFill>
                   </a:tcPr>
                 </a:tc>
               </a:tr>
-              <a:tr h="627017">
+              <a:tr h="548639">
                 <a:tc>
                   <a:txBody>
                     <a:bodyPr/>
                     <a:lstStyle/>
                     <a:p>
                       <a:r>
-                        <a:rPr sz="1600" b="1">
+                        <a:rPr sz="1400" b="1">
                           <a:solidFill>
                             <a:srgbClr val="1273DE"/>
                           </a:solidFill>
@@ -6236,7 +6653,7 @@
                       </a:r>
                     </a:p>
                   </a:txBody>
-                  <a:tcPr marL="109728">
+                  <a:tcPr marL="109728" marT="45720" marB="45720">
                     <a:solidFill>
                       <a:srgbClr val="FFFFFF"/>
                     </a:solidFill>
@@ -6248,41 +6665,41 @@
                     <a:lstStyle/>
                     <a:p>
                       <a:r>
-                        <a:rPr sz="1600" b="0">
+                        <a:rPr sz="1400" b="0">
                           <a:solidFill>
                             <a:srgbClr val="111111"/>
                           </a:solidFill>
                           <a:latin typeface="Calibri"/>
                         </a:rPr>
-                        <a:t>Gebucht, registriert, bestätigt immer. Teilgenommen nur am selben Tag.</a:t>
+                        <a:t>Gebucht, registriert und bestätigt immer. Teilgenommen nur in einen Termin am selben Tag. Stornierte, nicht erschienene und vor Ort aussortierte bleiben, wo sie sind.</a:t>
                       </a:r>
                     </a:p>
                   </a:txBody>
-                  <a:tcPr marL="109728">
+                  <a:tcPr marL="109728" marT="45720" marB="45720">
                     <a:solidFill>
                       <a:srgbClr val="FFFFFF"/>
                     </a:solidFill>
                   </a:tcPr>
                 </a:tc>
               </a:tr>
-              <a:tr h="627017">
+              <a:tr h="548639">
                 <a:tc>
                   <a:txBody>
                     <a:bodyPr/>
                     <a:lstStyle/>
                     <a:p>
                       <a:r>
-                        <a:rPr sz="1600" b="1">
+                        <a:rPr sz="1400" b="1">
                           <a:solidFill>
                             <a:srgbClr val="1273DE"/>
                           </a:solidFill>
                           <a:latin typeface="Calibri"/>
                         </a:rPr>
-                        <a:t>Verschieben: Nachricht</a:t>
+                        <a:t>Verschieben: Plätze</a:t>
                       </a:r>
                     </a:p>
                   </a:txBody>
-                  <a:tcPr marL="109728">
+                  <a:tcPr marL="109728" marT="45720" marB="45720">
                     <a:solidFill>
                       <a:srgbClr val="F1F3F5"/>
                     </a:solidFill>
@@ -6294,41 +6711,41 @@
                     <a:lstStyle/>
                     <a:p>
                       <a:r>
-                        <a:rPr sz="1600" b="0">
+                        <a:rPr sz="1400" b="0">
                           <a:solidFill>
                             <a:srgbClr val="111111"/>
                           </a:solidFill>
                           <a:latin typeface="Calibri"/>
                         </a:rPr>
-                        <a:t>Keine. Soll die Person Bescheid wissen, bitte selbst anschreiben.</a:t>
+                        <a:t>Hat der Zieltermin eine Platzzahl, werden nur so viele verschoben, wie Plätze frei sind. Wer nicht mehr passt, bleibt in Schulung A.</a:t>
                       </a:r>
                     </a:p>
                   </a:txBody>
-                  <a:tcPr marL="109728">
+                  <a:tcPr marL="109728" marT="45720" marB="45720">
                     <a:solidFill>
                       <a:srgbClr val="F1F3F5"/>
                     </a:solidFill>
                   </a:tcPr>
                 </a:tc>
               </a:tr>
-              <a:tr h="627017">
+              <a:tr h="548639">
                 <a:tc>
                   <a:txBody>
                     <a:bodyPr/>
                     <a:lstStyle/>
                     <a:p>
                       <a:r>
-                        <a:rPr sz="1600" b="1">
+                        <a:rPr sz="1400" b="1">
                           <a:solidFill>
                             <a:srgbClr val="1273DE"/>
                           </a:solidFill>
                           <a:latin typeface="Calibri"/>
                         </a:rPr>
-                        <a:t>Gruppengröße</a:t>
+                        <a:t>Verschieben: Nachricht</a:t>
                       </a:r>
                     </a:p>
                   </a:txBody>
-                  <a:tcPr marL="109728">
+                  <a:tcPr marL="109728" marT="45720" marB="45720">
                     <a:solidFill>
                       <a:srgbClr val="FFFFFF"/>
                     </a:solidFill>
@@ -6340,41 +6757,41 @@
                     <a:lstStyle/>
                     <a:p>
                       <a:r>
-                        <a:rPr sz="1600" b="0">
+                        <a:rPr sz="1400" b="0">
                           <a:solidFill>
                             <a:srgbClr val="111111"/>
                           </a:solidFill>
                           <a:latin typeface="Calibri"/>
                         </a:rPr>
-                        <a:t>Für kleinere Gruppen beim Termin eine kleinere Platzzahl eintragen.</a:t>
+                        <a:t>Keine. Wenn die Person Bescheid wissen soll, bitte selbst anschreiben.</a:t>
                       </a:r>
                     </a:p>
                   </a:txBody>
-                  <a:tcPr marL="109728">
+                  <a:tcPr marL="109728" marT="45720" marB="45720">
                     <a:solidFill>
                       <a:srgbClr val="FFFFFF"/>
                     </a:solidFill>
                   </a:tcPr>
                 </a:tc>
               </a:tr>
-              <a:tr h="627017">
+              <a:tr h="548639">
                 <a:tc>
                   <a:txBody>
                     <a:bodyPr/>
                     <a:lstStyle/>
                     <a:p>
                       <a:r>
-                        <a:rPr sz="1600" b="1">
+                        <a:rPr sz="1400" b="1">
                           <a:solidFill>
                             <a:srgbClr val="1273DE"/>
                           </a:solidFill>
                           <a:latin typeface="Calibri"/>
                         </a:rPr>
-                        <a:t>Vertragsbeginn geleert</a:t>
+                        <a:t>Gruppengröße</a:t>
                       </a:r>
                     </a:p>
                   </a:txBody>
-                  <a:tcPr marL="109728">
+                  <a:tcPr marL="109728" marT="45720" marB="45720">
                     <a:solidFill>
                       <a:srgbClr val="F1F3F5"/>
                     </a:solidFill>
@@ -6386,41 +6803,41 @@
                     <a:lstStyle/>
                     <a:p>
                       <a:r>
-                        <a:rPr sz="1600" b="0">
+                        <a:rPr sz="1400" b="0">
                           <a:solidFill>
                             <a:srgbClr val="111111"/>
                           </a:solidFill>
                           <a:latin typeface="Calibri"/>
                         </a:rPr>
-                        <a:t>Eine offene Versand-Vormerkung wird zurückgenommen.</a:t>
+                        <a:t>Für kleinere Gruppen beim Termin eine kleinere Platzzahl eintragen. Ist der Termin voll, landet niemand mehr darin.</a:t>
                       </a:r>
                     </a:p>
                   </a:txBody>
-                  <a:tcPr marL="109728">
+                  <a:tcPr marL="109728" marT="45720" marB="45720">
                     <a:solidFill>
                       <a:srgbClr val="F1F3F5"/>
                     </a:solidFill>
                   </a:tcPr>
                 </a:tc>
               </a:tr>
-              <a:tr h="627017">
+              <a:tr h="548644">
                 <a:tc>
                   <a:txBody>
                     <a:bodyPr/>
                     <a:lstStyle/>
                     <a:p>
                       <a:r>
-                        <a:rPr sz="1600" b="1">
+                        <a:rPr sz="1400" b="1">
                           <a:solidFill>
                             <a:srgbClr val="1273DE"/>
                           </a:solidFill>
                           <a:latin typeface="Calibri"/>
                         </a:rPr>
-                        <a:t>Nach dem Versand</a:t>
+                        <a:t>Vertragsdaten</a:t>
                       </a:r>
                     </a:p>
                   </a:txBody>
-                  <a:tcPr marL="109728">
+                  <a:tcPr marL="109728" marT="45720" marB="45720">
                     <a:solidFill>
                       <a:srgbClr val="FFFFFF"/>
                     </a:solidFill>
@@ -6432,41 +6849,327 @@
                     <a:lstStyle/>
                     <a:p>
                       <a:r>
-                        <a:rPr sz="1600" b="0">
+                        <a:rPr sz="1400" b="0">
                           <a:solidFill>
                             <a:srgbClr val="111111"/>
                           </a:solidFill>
                           <a:latin typeface="Calibri"/>
                         </a:rPr>
-                        <a:t>Es gelten die Daten im Vertrag. Änderung über „Vertrag neu ausstellen“.</a:t>
+                        <a:t>Leert ihr den Vertragsbeginn bei jemandem, der für den Versand vorgemerkt ist, wird die Vormerkung zurückgenommen. Nach dem Versand gelten die Daten im Vertrag.</a:t>
                       </a:r>
                     </a:p>
                   </a:txBody>
-                  <a:tcPr marL="109728">
+                  <a:tcPr marL="109728" marT="45720" marB="45720">
                     <a:solidFill>
                       <a:srgbClr val="FFFFFF"/>
                     </a:solidFill>
                   </a:tcPr>
                 </a:tc>
               </a:tr>
-              <a:tr h="627018">
+            </a:tbl>
+          </a:graphicData>
+        </a:graphic>
+      </p:graphicFrame>
+    </p:spTree>
+  </p:cSld>
+  <p:clrMapOvr>
+    <a:masterClrMapping/>
+  </p:clrMapOvr>
+</p:sld>
+</file>
+
+<file path=ppt/slides/slide9.xml><?xml version="1.0" encoding="utf-8"?>
+<p:sld xmlns:a="http://schemas.openxmlformats.org/drawingml/2006/main" xmlns:p="http://schemas.openxmlformats.org/presentationml/2006/main" xmlns:r="http://schemas.openxmlformats.org/officeDocument/2006/relationships">
+  <p:cSld>
+    <p:spTree>
+      <p:nvGrpSpPr>
+        <p:cNvPr id="1" name=""/>
+        <p:cNvGrpSpPr/>
+        <p:nvPr/>
+      </p:nvGrpSpPr>
+      <p:grpSpPr/>
+      <p:sp>
+        <p:nvSpPr>
+          <p:cNvPr id="2" name="Rectangle 1"/>
+          <p:cNvSpPr/>
+          <p:nvPr/>
+        </p:nvSpPr>
+        <p:spPr>
+          <a:xfrm>
+            <a:off x="0" y="0"/>
+            <a:ext cx="155448" cy="6858000"/>
+          </a:xfrm>
+          <a:prstGeom prst="rect">
+            <a:avLst/>
+          </a:prstGeom>
+          <a:solidFill>
+            <a:srgbClr val="1273DE"/>
+          </a:solidFill>
+          <a:ln>
+            <a:noFill/>
+          </a:ln>
+        </p:spPr>
+        <p:style>
+          <a:lnRef idx="1">
+            <a:schemeClr val="accent1"/>
+          </a:lnRef>
+          <a:fillRef idx="3">
+            <a:schemeClr val="accent1"/>
+          </a:fillRef>
+          <a:effectRef idx="2">
+            <a:schemeClr val="accent1"/>
+          </a:effectRef>
+          <a:fontRef idx="minor">
+            <a:schemeClr val="lt1"/>
+          </a:fontRef>
+        </p:style>
+        <p:txBody>
+          <a:bodyPr rtlCol="0" anchor="ctr"/>
+          <a:lstStyle/>
+          <a:p>
+            <a:pPr algn="ctr"/>
+          </a:p>
+        </p:txBody>
+      </p:sp>
+      <p:sp>
+        <p:nvSpPr>
+          <p:cNvPr id="3" name="TextBox 2"/>
+          <p:cNvSpPr txBox="1"/>
+          <p:nvPr/>
+        </p:nvSpPr>
+        <p:spPr>
+          <a:xfrm>
+            <a:off x="612648" y="329184"/>
+            <a:ext cx="10479024" cy="274320"/>
+          </a:xfrm>
+          <a:prstGeom prst="rect">
+            <a:avLst/>
+          </a:prstGeom>
+          <a:noFill/>
+        </p:spPr>
+        <p:txBody>
+          <a:bodyPr wrap="square" anchor="t" lIns="45720" rIns="45720">
+            <a:spAutoFit/>
+          </a:bodyPr>
+          <a:lstStyle/>
+          <a:p>
+            <a:pPr algn="l">
+              <a:spcAft>
+                <a:spcPts val="719"/>
+              </a:spcAft>
+            </a:pPr>
+            <a:r>
+              <a:rPr sz="1200" b="1">
+                <a:solidFill>
+                  <a:srgbClr val="1273DE"/>
+                </a:solidFill>
+                <a:latin typeface="Calibri"/>
+              </a:rPr>
+              <a:t>GUT ZU WISSEN · KAMPAGNE „SCHULUNG VOLL“</a:t>
+            </a:r>
+          </a:p>
+        </p:txBody>
+      </p:sp>
+      <p:sp>
+        <p:nvSpPr>
+          <p:cNvPr id="4" name="TextBox 3"/>
+          <p:cNvSpPr txBox="1"/>
+          <p:nvPr/>
+        </p:nvSpPr>
+        <p:spPr>
+          <a:xfrm>
+            <a:off x="612648" y="731520"/>
+            <a:ext cx="10936224" cy="640080"/>
+          </a:xfrm>
+          <a:prstGeom prst="rect">
+            <a:avLst/>
+          </a:prstGeom>
+          <a:noFill/>
+        </p:spPr>
+        <p:txBody>
+          <a:bodyPr wrap="square" anchor="t" lIns="45720" rIns="45720">
+            <a:spAutoFit/>
+          </a:bodyPr>
+          <a:lstStyle/>
+          <a:p>
+            <a:pPr algn="l">
+              <a:spcAft>
+                <a:spcPts val="1709"/>
+              </a:spcAft>
+            </a:pPr>
+            <a:r>
+              <a:rPr sz="2850" b="1">
+                <a:solidFill>
+                  <a:srgbClr val="111111"/>
+                </a:solidFill>
+                <a:latin typeface="Calibri"/>
+              </a:rPr>
+              <a:t>Regeln auf einen Blick</a:t>
+            </a:r>
+          </a:p>
+        </p:txBody>
+      </p:sp>
+      <p:sp>
+        <p:nvSpPr>
+          <p:cNvPr id="5" name="Rectangle 4"/>
+          <p:cNvSpPr/>
+          <p:nvPr/>
+        </p:nvSpPr>
+        <p:spPr>
+          <a:xfrm>
+            <a:off x="512064" y="1435608"/>
+            <a:ext cx="11128248" cy="9144"/>
+          </a:xfrm>
+          <a:prstGeom prst="rect">
+            <a:avLst/>
+          </a:prstGeom>
+          <a:solidFill>
+            <a:srgbClr val="B8BCC4"/>
+          </a:solidFill>
+          <a:ln>
+            <a:noFill/>
+          </a:ln>
+        </p:spPr>
+        <p:style>
+          <a:lnRef idx="1">
+            <a:schemeClr val="accent1"/>
+          </a:lnRef>
+          <a:fillRef idx="3">
+            <a:schemeClr val="accent1"/>
+          </a:fillRef>
+          <a:effectRef idx="2">
+            <a:schemeClr val="accent1"/>
+          </a:effectRef>
+          <a:fontRef idx="minor">
+            <a:schemeClr val="lt1"/>
+          </a:fontRef>
+        </p:style>
+        <p:txBody>
+          <a:bodyPr rtlCol="0" anchor="ctr"/>
+          <a:lstStyle/>
+          <a:p>
+            <a:pPr algn="ctr"/>
+          </a:p>
+        </p:txBody>
+      </p:sp>
+      <p:sp>
+        <p:nvSpPr>
+          <p:cNvPr id="6" name="TextBox 5"/>
+          <p:cNvSpPr txBox="1"/>
+          <p:nvPr/>
+        </p:nvSpPr>
+        <p:spPr>
+          <a:xfrm>
+            <a:off x="612648" y="6419088"/>
+            <a:ext cx="6190488" cy="274320"/>
+          </a:xfrm>
+          <a:prstGeom prst="rect">
+            <a:avLst/>
+          </a:prstGeom>
+          <a:noFill/>
+        </p:spPr>
+        <p:txBody>
+          <a:bodyPr wrap="square" anchor="t" lIns="45720" rIns="45720">
+            <a:spAutoFit/>
+          </a:bodyPr>
+          <a:lstStyle/>
+          <a:p>
+            <a:pPr algn="l">
+              <a:spcAft>
+                <a:spcPts val="630"/>
+              </a:spcAft>
+            </a:pPr>
+            <a:r>
+              <a:rPr sz="1050" b="0">
+                <a:solidFill>
+                  <a:srgbClr val="5F6368"/>
+                </a:solidFill>
+                <a:latin typeface="Calibri"/>
+              </a:rPr>
+              <a:t>RheinGedeck · Intern</a:t>
+            </a:r>
+          </a:p>
+        </p:txBody>
+      </p:sp>
+      <p:sp>
+        <p:nvSpPr>
+          <p:cNvPr id="7" name="TextBox 6"/>
+          <p:cNvSpPr txBox="1"/>
+          <p:nvPr/>
+        </p:nvSpPr>
+        <p:spPr>
+          <a:xfrm>
+            <a:off x="11009376" y="6419088"/>
+            <a:ext cx="530352" cy="274320"/>
+          </a:xfrm>
+          <a:prstGeom prst="rect">
+            <a:avLst/>
+          </a:prstGeom>
+          <a:noFill/>
+        </p:spPr>
+        <p:txBody>
+          <a:bodyPr wrap="square" anchor="t" lIns="45720" rIns="45720">
+            <a:spAutoFit/>
+          </a:bodyPr>
+          <a:lstStyle/>
+          <a:p>
+            <a:pPr algn="r">
+              <a:spcAft>
+                <a:spcPts val="630"/>
+              </a:spcAft>
+            </a:pPr>
+            <a:r>
+              <a:rPr sz="1050" b="0">
+                <a:solidFill>
+                  <a:srgbClr val="5F6368"/>
+                </a:solidFill>
+                <a:latin typeface="Calibri"/>
+              </a:rPr>
+              <a:t>09</a:t>
+            </a:r>
+          </a:p>
+        </p:txBody>
+      </p:sp>
+      <p:graphicFrame>
+        <p:nvGraphicFramePr>
+          <p:cNvPr id="8" name="Table 7"/>
+          <p:cNvGraphicFramePr>
+            <a:graphicFrameLocks noGrp="1"/>
+          </p:cNvGraphicFramePr>
+          <p:nvPr/>
+        </p:nvGraphicFramePr>
+        <p:xfrm>
+          <a:off x="685800" y="1737360"/>
+          <a:ext cx="10789920" cy="2743200"/>
+        </p:xfrm>
+        <a:graphic>
+          <a:graphicData uri="http://schemas.openxmlformats.org/drawingml/2006/table">
+            <a:tbl>
+              <a:tblPr bandRow="1">
+                <a:tableStyleId>{5C22544A-7EE6-4342-B048-85BDC9FD1C3A}</a:tableStyleId>
+              </a:tblPr>
+              <a:tblGrid>
+                <a:gridCol w="3017520"/>
+                <a:gridCol w="7772400"/>
+              </a:tblGrid>
+              <a:tr h="548640">
                 <a:tc>
                   <a:txBody>
                     <a:bodyPr/>
                     <a:lstStyle/>
                     <a:p>
                       <a:r>
-                        <a:rPr sz="1600" b="1">
+                        <a:rPr sz="1400" b="1">
                           <a:solidFill>
                             <a:srgbClr val="1273DE"/>
                           </a:solidFill>
                           <a:latin typeface="Calibri"/>
                         </a:rPr>
-                        <a:t>Kampagne: doppelt</a:t>
+                        <a:t>Kampagne: wer bekommt sie</a:t>
                       </a:r>
                     </a:p>
                   </a:txBody>
-                  <a:tcPr marL="109728">
+                  <a:tcPr marL="109728" marT="45720" marB="45720">
                     <a:solidFill>
                       <a:srgbClr val="F1F3F5"/>
                     </a:solidFill>
@@ -6478,17 +7181,201 @@
                     <a:lstStyle/>
                     <a:p>
                       <a:r>
-                        <a:rPr sz="1600" b="0">
+                        <a:rPr sz="1400" b="0">
                           <a:solidFill>
                             <a:srgbClr val="111111"/>
                           </a:solidFill>
                           <a:latin typeface="Calibri"/>
                         </a:rPr>
-                        <a:t>Wer in 14 Tagen schon eine Kampagne bekam, ist vorsichtshalber abgehakt.</a:t>
+                        <a:t>Nur Bewerber, die Phase 1 abgeschlossen haben und in der Terminauswahl stehen. Wer die Bewerbung noch nicht vervollständigt hat, bleibt sichtbar, ist aber gesperrt.</a:t>
                       </a:r>
                     </a:p>
                   </a:txBody>
-                  <a:tcPr marL="109728">
+                  <a:tcPr marL="109728" marT="45720" marB="45720">
+                    <a:solidFill>
+                      <a:srgbClr val="F1F3F5"/>
+                    </a:solidFill>
+                  </a:tcPr>
+                </a:tc>
+              </a:tr>
+              <a:tr h="548640">
+                <a:tc>
+                  <a:txBody>
+                    <a:bodyPr/>
+                    <a:lstStyle/>
+                    <a:p>
+                      <a:r>
+                        <a:rPr sz="1400" b="1">
+                          <a:solidFill>
+                            <a:srgbClr val="1273DE"/>
+                          </a:solidFill>
+                          <a:latin typeface="Calibri"/>
+                        </a:rPr>
+                        <a:t>Kampagne: danach</a:t>
+                      </a:r>
+                    </a:p>
+                  </a:txBody>
+                  <a:tcPr marL="109728" marT="45720" marB="45720">
+                    <a:solidFill>
+                      <a:srgbClr val="FFFFFF"/>
+                    </a:solidFill>
+                  </a:tcPr>
+                </a:tc>
+                <a:tc>
+                  <a:txBody>
+                    <a:bodyPr/>
+                    <a:lstStyle/>
+                    <a:p>
+                      <a:r>
+                        <a:rPr sz="1400" b="0">
+                          <a:solidFill>
+                            <a:srgbClr val="111111"/>
+                          </a:solidFill>
+                          <a:latin typeface="Calibri"/>
+                        </a:rPr>
+                        <a:t>Keine automatischen Erinnerungen. Bucht die Person einen Termin, läuft alles wie gewohnt weiter: Daten vervollständigen, Bestätigung, Vertrag.</a:t>
+                      </a:r>
+                    </a:p>
+                  </a:txBody>
+                  <a:tcPr marL="109728" marT="45720" marB="45720">
+                    <a:solidFill>
+                      <a:srgbClr val="FFFFFF"/>
+                    </a:solidFill>
+                  </a:tcPr>
+                </a:tc>
+              </a:tr>
+              <a:tr h="548640">
+                <a:tc>
+                  <a:txBody>
+                    <a:bodyPr/>
+                    <a:lstStyle/>
+                    <a:p>
+                      <a:r>
+                        <a:rPr sz="1400" b="1">
+                          <a:solidFill>
+                            <a:srgbClr val="1273DE"/>
+                          </a:solidFill>
+                          <a:latin typeface="Calibri"/>
+                        </a:rPr>
+                        <a:t>Kampagne: doppelt</a:t>
+                      </a:r>
+                    </a:p>
+                  </a:txBody>
+                  <a:tcPr marL="109728" marT="45720" marB="45720">
+                    <a:solidFill>
+                      <a:srgbClr val="F1F3F5"/>
+                    </a:solidFill>
+                  </a:tcPr>
+                </a:tc>
+                <a:tc>
+                  <a:txBody>
+                    <a:bodyPr/>
+                    <a:lstStyle/>
+                    <a:p>
+                      <a:r>
+                        <a:rPr sz="1400" b="0">
+                          <a:solidFill>
+                            <a:srgbClr val="111111"/>
+                          </a:solidFill>
+                          <a:latin typeface="Calibri"/>
+                        </a:rPr>
+                        <a:t>Wer in den letzten 14 Tagen schon eine Kampagne bekam, ist vorsichtshalber abgehakt (Badge „angeschrieben am …“). Haken setzen geht trotzdem.</a:t>
+                      </a:r>
+                    </a:p>
+                  </a:txBody>
+                  <a:tcPr marL="109728" marT="45720" marB="45720">
+                    <a:solidFill>
+                      <a:srgbClr val="F1F3F5"/>
+                    </a:solidFill>
+                  </a:tcPr>
+                </a:tc>
+              </a:tr>
+              <a:tr h="548640">
+                <a:tc>
+                  <a:txBody>
+                    <a:bodyPr/>
+                    <a:lstStyle/>
+                    <a:p>
+                      <a:r>
+                        <a:rPr sz="1400" b="1">
+                          <a:solidFill>
+                            <a:srgbClr val="1273DE"/>
+                          </a:solidFill>
+                          <a:latin typeface="Calibri"/>
+                        </a:rPr>
+                        <a:t>Kampagne: Ausschreibungswechsel</a:t>
+                      </a:r>
+                    </a:p>
+                  </a:txBody>
+                  <a:tcPr marL="109728" marT="45720" marB="45720">
+                    <a:solidFill>
+                      <a:srgbClr val="FFFFFF"/>
+                    </a:solidFill>
+                  </a:tcPr>
+                </a:tc>
+                <a:tc>
+                  <a:txBody>
+                    <a:bodyPr/>
+                    <a:lstStyle/>
+                    <a:p>
+                      <a:r>
+                        <a:rPr sz="1400" b="0">
+                          <a:solidFill>
+                            <a:srgbClr val="111111"/>
+                          </a:solidFill>
+                          <a:latin typeface="Calibri"/>
+                        </a:rPr>
+                        <a:t>Bucht jemand am selben Ort eine Schulung einer anderen Ausschreibung, bleibt er in seiner Ausschreibung. In der Statistik seht ihr ihn beim neuen Termin unter „Herkunft“.</a:t>
+                      </a:r>
+                    </a:p>
+                  </a:txBody>
+                  <a:tcPr marL="109728" marT="45720" marB="45720">
+                    <a:solidFill>
+                      <a:srgbClr val="FFFFFF"/>
+                    </a:solidFill>
+                  </a:tcPr>
+                </a:tc>
+              </a:tr>
+              <a:tr h="548640">
+                <a:tc>
+                  <a:txBody>
+                    <a:bodyPr/>
+                    <a:lstStyle/>
+                    <a:p>
+                      <a:r>
+                        <a:rPr sz="1400" b="1">
+                          <a:solidFill>
+                            <a:srgbClr val="1273DE"/>
+                          </a:solidFill>
+                          <a:latin typeface="Calibri"/>
+                        </a:rPr>
+                        <a:t>Vorlage pflegen</a:t>
+                      </a:r>
+                    </a:p>
+                  </a:txBody>
+                  <a:tcPr marL="109728" marT="45720" marB="45720">
+                    <a:solidFill>
+                      <a:srgbClr val="F1F3F5"/>
+                    </a:solidFill>
+                  </a:tcPr>
+                </a:tc>
+                <a:tc>
+                  <a:txBody>
+                    <a:bodyPr/>
+                    <a:lstStyle/>
+                    <a:p>
+                      <a:r>
+                        <a:rPr sz="1400" b="0">
+                          <a:solidFill>
+                            <a:srgbClr val="111111"/>
+                          </a:solidFill>
+                          <a:latin typeface="Calibri"/>
+                        </a:rPr>
+                        <a:t>Bewerberliste → Einstellungen → „WhatsApp Template — Schulung voll, freie Termine“. Ohne Auswahl greift die normale Terminauswahl-Vorlage.</a:t>
+                      </a:r>
+                    </a:p>
+                  </a:txBody>
+                  <a:tcPr marL="109728" marT="45720" marB="45720">
                     <a:solidFill>
                       <a:srgbClr val="F1F3F5"/>
                     </a:solidFill>

</xml_diff>

<commit_message>
docs(recruiting): Anleitung Schulungstermine umplanen = PDF vom 06.10. aktualisiert, ohne Mail-Themen
Umfang wie die Anleitung vom 06.10. (Verschieben, Kampagne, Gut zu wissen),
aktualisiert um Verschieben waehrend der Schulung und mit Teilgenommenen.
Nachbereitung/Vertragsdaten und Statusfilter als eigener Baustein.

Co-Authored-By: Claude Opus 5.5 <noreply@anthropic.com>
</commit_message>
<xml_diff>
--- a/docs/anleitungen/folien/2026-10-08-schulungstermine-umplanen.pptx
+++ b/docs/anleitungen/folien/2026-10-08-schulungstermine-umplanen.pptx
@@ -12,8 +12,6 @@
     <p:sldId id="260" r:id="rId11"/>
     <p:sldId id="261" r:id="rId12"/>
     <p:sldId id="262" r:id="rId13"/>
-    <p:sldId id="263" r:id="rId14"/>
-    <p:sldId id="264" r:id="rId15"/>
   </p:sldIdLst>
   <p:sldSz cx="12192000" cy="6858000" type="screen4x3"/>
   <p:notesSz cx="6858000" cy="9144000"/>
@@ -4079,7 +4077,7 @@
                 </a:solidFill>
                 <a:latin typeface="Calibri"/>
               </a:rPr>
-              <a:t>NEU · WÄHREND DER SCHULUNG</a:t>
+              <a:t>TEILNEHMER VERSCHIEBEN · WÄHREND DER SCHULUNG</a:t>
             </a:r>
           </a:p>
         </p:txBody>
@@ -4278,7 +4276,7 @@
                 </a:solidFill>
                 <a:latin typeface="Calibri"/>
               </a:rPr>
-              <a:t>Verschieben geht jetzt auch, während der Termin läuft, und auch mit Teilnehmern, die schon auf </a:t>
+              <a:t>Verschieben geht auch, solange der Termin läuft, und auch mit Teilnehmern, die schon auf </a:t>
             </a:r>
             <a:r>
               <a:rPr sz="1800" b="1">
@@ -4535,7 +4533,7 @@
                 </a:solidFill>
                 <a:latin typeface="Calibri"/>
               </a:rPr>
-              <a:t>VOR DER SCHULUNG</a:t>
+              <a:t>WENN EINE SCHULUNG VOLL IST · SCHRITT 1</a:t>
             </a:r>
           </a:p>
         </p:txBody>
@@ -4574,7 +4572,7 @@
                 </a:solidFill>
                 <a:latin typeface="Calibri"/>
               </a:rPr>
-              <a:t>Nach Status filtern, auch „Keine Reaktion“</a:t>
+              <a:t>Bewerber ohne Termin finden</a:t>
             </a:r>
           </a:p>
         </p:txBody>
@@ -4708,90 +4706,8 @@
         </p:nvSpPr>
         <p:spPr>
           <a:xfrm>
-            <a:off x="685800" y="1773936"/>
-            <a:ext cx="3291840" cy="3657600"/>
-          </a:xfrm>
-          <a:prstGeom prst="rect">
-            <a:avLst/>
-          </a:prstGeom>
-          <a:noFill/>
-        </p:spPr>
-        <p:txBody>
-          <a:bodyPr wrap="square" anchor="t" lIns="45720" rIns="45720">
-            <a:spAutoFit/>
-          </a:bodyPr>
-          <a:lstStyle/>
-          <a:p>
-            <a:pPr algn="l">
-              <a:spcAft>
-                <a:spcPts val="1019"/>
-              </a:spcAft>
-            </a:pPr>
-            <a:r>
-              <a:rPr sz="1700" b="0">
-                <a:solidFill>
-                  <a:srgbClr val="111111"/>
-                </a:solidFill>
-                <a:latin typeface="Calibri"/>
-              </a:rPr>
-              <a:t>Oben in der Liste das Feld </a:t>
-            </a:r>
-            <a:r>
-              <a:rPr sz="1700" b="1">
-                <a:solidFill>
-                  <a:srgbClr val="111111"/>
-                </a:solidFill>
-                <a:latin typeface="Calibri"/>
-              </a:rPr>
-              <a:t>Status</a:t>
-            </a:r>
-            <a:r>
-              <a:rPr sz="1700" b="0">
-                <a:solidFill>
-                  <a:srgbClr val="111111"/>
-                </a:solidFill>
-                <a:latin typeface="Calibri"/>
-              </a:rPr>
-              <a:t> öffnen. Der Filter gilt in der Übersicht und im Reiter „Nach der Schulung“.</a:t>
-            </a:r>
-          </a:p>
-          <a:p>
-            <a:pPr algn="l">
-              <a:spcAft>
-                <a:spcPts val="1019"/>
-              </a:spcAft>
-            </a:pPr>
-            <a:r>
-              <a:rPr sz="1700" b="1">
-                <a:solidFill>
-                  <a:srgbClr val="111111"/>
-                </a:solidFill>
-                <a:latin typeface="Calibri"/>
-              </a:rPr>
-              <a:t>Keine Reaktion</a:t>
-            </a:r>
-            <a:r>
-              <a:rPr sz="1700" b="0">
-                <a:solidFill>
-                  <a:srgbClr val="111111"/>
-                </a:solidFill>
-                <a:latin typeface="Calibri"/>
-              </a:rPr>
-              <a:t> zeigt Gebuchte, die auf die Erinnerungen nicht reagiert haben. Ihr Platz ist wieder frei.</a:t>
-            </a:r>
-          </a:p>
-        </p:txBody>
-      </p:sp>
-      <p:sp>
-        <p:nvSpPr>
-          <p:cNvPr id="9" name="TextBox 8"/>
-          <p:cNvSpPr txBox="1"/>
-          <p:nvPr/>
-        </p:nvSpPr>
-        <p:spPr>
-          <a:xfrm>
-            <a:off x="685800" y="5257800"/>
-            <a:ext cx="3291840" cy="1005840"/>
+            <a:off x="685800" y="1600200"/>
+            <a:ext cx="10789920" cy="731520"/>
           </a:xfrm>
           <a:prstGeom prst="rect">
             <a:avLst/>
@@ -4810,46 +4726,240 @@
               </a:spcAft>
             </a:pPr>
             <a:r>
-              <a:rPr sz="1600" b="1">
-                <a:solidFill>
-                  <a:srgbClr val="1273DE"/>
-                </a:solidFill>
-                <a:latin typeface="Calibri"/>
-              </a:rPr>
-              <a:t>Praktisch zum Nachtelefonieren vor der Schulung.</a:t>
-            </a:r>
-          </a:p>
-        </p:txBody>
-      </p:sp>
-      <p:pic>
-        <p:nvPicPr>
-          <p:cNvPr id="10" name="Picture 9" descr="E_statusfilter.png"/>
-          <p:cNvPicPr>
-            <a:picLocks noChangeAspect="1"/>
-          </p:cNvPicPr>
+              <a:rPr sz="1600" b="0">
+                <a:solidFill>
+                  <a:srgbClr val="5F6368"/>
+                </a:solidFill>
+                <a:latin typeface="Calibri"/>
+              </a:rPr>
+              <a:t>Ist ein kommender Termin ausgebucht, schreibt ihr mit einem Klick alle Bewerber dieser Ausschreibung ohne Termin an. Sie bekommen eine WhatsApp mit dem Link zur Terminauswahl und buchen sich selbst in einen anderen Termin.</a:t>
+            </a:r>
+          </a:p>
+        </p:txBody>
+      </p:sp>
+      <p:sp>
+        <p:nvSpPr>
+          <p:cNvPr id="9" name="TextBox 8"/>
+          <p:cNvSpPr txBox="1"/>
           <p:nvPr/>
-        </p:nvPicPr>
-        <p:blipFill>
-          <a:blip r:embed="rId2"/>
-          <a:stretch>
-            <a:fillRect/>
-          </a:stretch>
-        </p:blipFill>
-        <p:spPr>
-          <a:xfrm>
-            <a:off x="4160520" y="1875055"/>
-            <a:ext cx="7360920" cy="4205169"/>
+        </p:nvSpPr>
+        <p:spPr>
+          <a:xfrm>
+            <a:off x="685800" y="2514600"/>
+            <a:ext cx="5212080" cy="2880360"/>
           </a:xfrm>
           <a:prstGeom prst="rect">
             <a:avLst/>
           </a:prstGeom>
-          <a:ln w="9525">
-            <a:solidFill>
-              <a:srgbClr val="B8BCC4"/>
-            </a:solidFill>
-          </a:ln>
-        </p:spPr>
-      </p:pic>
+          <a:noFill/>
+        </p:spPr>
+        <p:txBody>
+          <a:bodyPr wrap="square" anchor="t" lIns="45720" rIns="45720">
+            <a:spAutoFit/>
+          </a:bodyPr>
+          <a:lstStyle/>
+          <a:p>
+            <a:pPr algn="l">
+              <a:spcAft>
+                <a:spcPts val="1080"/>
+              </a:spcAft>
+            </a:pPr>
+            <a:r>
+              <a:rPr sz="1800" b="0">
+                <a:solidFill>
+                  <a:srgbClr val="111111"/>
+                </a:solidFill>
+                <a:latin typeface="Calibri"/>
+              </a:rPr>
+              <a:t>1. </a:t>
+            </a:r>
+            <a:r>
+              <a:rPr sz="1800" b="1">
+                <a:solidFill>
+                  <a:srgbClr val="111111"/>
+                </a:solidFill>
+                <a:latin typeface="Calibri"/>
+              </a:rPr>
+              <a:t>Statistik</a:t>
+            </a:r>
+            <a:r>
+              <a:rPr sz="1800" b="0">
+                <a:solidFill>
+                  <a:srgbClr val="111111"/>
+                </a:solidFill>
+                <a:latin typeface="Calibri"/>
+              </a:rPr>
+              <a:t> öffnen, Filiale wählen, nach unten zur Tabelle </a:t>
+            </a:r>
+            <a:r>
+              <a:rPr sz="1800" b="1">
+                <a:solidFill>
+                  <a:srgbClr val="111111"/>
+                </a:solidFill>
+                <a:latin typeface="Calibri"/>
+              </a:rPr>
+              <a:t>„Schulungstermine“</a:t>
+            </a:r>
+            <a:r>
+              <a:rPr sz="1800" b="0">
+                <a:solidFill>
+                  <a:srgbClr val="111111"/>
+                </a:solidFill>
+                <a:latin typeface="Calibri"/>
+              </a:rPr>
+              <a:t> scrollen.</a:t>
+            </a:r>
+          </a:p>
+          <a:p>
+            <a:pPr algn="l">
+              <a:spcAft>
+                <a:spcPts val="1080"/>
+              </a:spcAft>
+            </a:pPr>
+            <a:r>
+              <a:rPr sz="1800" b="0">
+                <a:solidFill>
+                  <a:srgbClr val="111111"/>
+                </a:solidFill>
+                <a:latin typeface="Calibri"/>
+              </a:rPr>
+              <a:t>2. Am vollen Termin steht in der Spalte Ausschreibung das Badge </a:t>
+            </a:r>
+            <a:r>
+              <a:rPr sz="1800" b="1">
+                <a:solidFill>
+                  <a:srgbClr val="111111"/>
+                </a:solidFill>
+                <a:latin typeface="Calibri"/>
+              </a:rPr>
+              <a:t>„Ausgebucht“</a:t>
+            </a:r>
+            <a:r>
+              <a:rPr sz="1800" b="0">
+                <a:solidFill>
+                  <a:srgbClr val="111111"/>
+                </a:solidFill>
+                <a:latin typeface="Calibri"/>
+              </a:rPr>
+              <a:t> und daneben die Pille </a:t>
+            </a:r>
+            <a:r>
+              <a:rPr sz="1800" b="1">
+                <a:solidFill>
+                  <a:srgbClr val="111111"/>
+                </a:solidFill>
+                <a:latin typeface="Calibri"/>
+              </a:rPr>
+              <a:t>„N ohne Termin“</a:t>
+            </a:r>
+            <a:r>
+              <a:rPr sz="1800" b="0">
+                <a:solidFill>
+                  <a:srgbClr val="111111"/>
+                </a:solidFill>
+                <a:latin typeface="Calibri"/>
+              </a:rPr>
+              <a:t>. Auf die Pille klicken.</a:t>
+            </a:r>
+          </a:p>
+        </p:txBody>
+      </p:sp>
+      <p:sp>
+        <p:nvSpPr>
+          <p:cNvPr id="10" name="TextBox 9"/>
+          <p:cNvSpPr txBox="1"/>
+          <p:nvPr/>
+        </p:nvSpPr>
+        <p:spPr>
+          <a:xfrm>
+            <a:off x="6263640" y="2514600"/>
+            <a:ext cx="5212080" cy="2880360"/>
+          </a:xfrm>
+          <a:prstGeom prst="rect">
+            <a:avLst/>
+          </a:prstGeom>
+          <a:noFill/>
+        </p:spPr>
+        <p:txBody>
+          <a:bodyPr wrap="square" anchor="t" lIns="45720" rIns="45720">
+            <a:spAutoFit/>
+          </a:bodyPr>
+          <a:lstStyle/>
+          <a:p>
+            <a:pPr algn="l">
+              <a:spcAft>
+                <a:spcPts val="1080"/>
+              </a:spcAft>
+            </a:pPr>
+            <a:r>
+              <a:rPr sz="1800" b="0">
+                <a:solidFill>
+                  <a:srgbClr val="111111"/>
+                </a:solidFill>
+                <a:latin typeface="Calibri"/>
+              </a:rPr>
+              <a:t>3. Oben im Fenster steht der Anlass: welcher Termin voll ist und wie viele weitere Termine mit freien Plätzen es an dieser Stelle gibt. </a:t>
+            </a:r>
+            <a:r>
+              <a:rPr sz="1800" b="1">
+                <a:solidFill>
+                  <a:srgbClr val="111111"/>
+                </a:solidFill>
+                <a:latin typeface="Calibri"/>
+              </a:rPr>
+              <a:t>Ist die Karte rot, gibt es keine Alternative.</a:t>
+            </a:r>
+            <a:r>
+              <a:rPr sz="1800" b="0">
+                <a:solidFill>
+                  <a:srgbClr val="111111"/>
+                </a:solidFill>
+                <a:latin typeface="Calibri"/>
+              </a:rPr>
+              <a:t> Dann erst einen neuen Termin anlegen.</a:t>
+            </a:r>
+          </a:p>
+        </p:txBody>
+      </p:sp>
+      <p:sp>
+        <p:nvSpPr>
+          <p:cNvPr id="11" name="TextBox 10"/>
+          <p:cNvSpPr txBox="1"/>
+          <p:nvPr/>
+        </p:nvSpPr>
+        <p:spPr>
+          <a:xfrm>
+            <a:off x="685800" y="5486400"/>
+            <a:ext cx="10789920" cy="731520"/>
+          </a:xfrm>
+          <a:prstGeom prst="rect">
+            <a:avLst/>
+          </a:prstGeom>
+          <a:noFill/>
+        </p:spPr>
+        <p:txBody>
+          <a:bodyPr wrap="square" anchor="t" lIns="45720" rIns="45720">
+            <a:spAutoFit/>
+          </a:bodyPr>
+          <a:lstStyle/>
+          <a:p>
+            <a:pPr algn="l">
+              <a:spcAft>
+                <a:spcPts val="960"/>
+              </a:spcAft>
+            </a:pPr>
+            <a:r>
+              <a:rPr sz="1600" b="0">
+                <a:solidFill>
+                  <a:srgbClr val="5F6368"/>
+                </a:solidFill>
+                <a:latin typeface="Calibri"/>
+              </a:rPr>
+              <a:t>Die Pille erscheint nur bei Platzzahl, voll belegt, künftigem Termin und hinterlegter Ausschreibung. Fehlt die Ausschreibung, steht nur das Badge mit „keine Ausschreibung“.</a:t>
+            </a:r>
+          </a:p>
+        </p:txBody>
+      </p:sp>
     </p:spTree>
   </p:cSld>
   <p:clrMapOvr>
@@ -4945,7 +5055,7 @@
                 </a:solidFill>
                 <a:latin typeface="Calibri"/>
               </a:rPr>
-              <a:t>WENN EINE SCHULUNG VOLL IST · SCHRITT 1</a:t>
+              <a:t>WENN EINE SCHULUNG VOLL IST · SCHRITT 2</a:t>
             </a:r>
           </a:p>
         </p:txBody>
@@ -4984,7 +5094,7 @@
                 </a:solidFill>
                 <a:latin typeface="Calibri"/>
               </a:rPr>
-              <a:t>Bewerber ohne Termin finden</a:t>
+              <a:t>Empfänger prüfen und senden</a:t>
             </a:r>
           </a:p>
         </p:txBody>
@@ -5118,7 +5228,155 @@
         </p:nvSpPr>
         <p:spPr>
           <a:xfrm>
-            <a:off x="685800" y="1600200"/>
+            <a:off x="685800" y="1773936"/>
+            <a:ext cx="5212080" cy="3621024"/>
+          </a:xfrm>
+          <a:prstGeom prst="rect">
+            <a:avLst/>
+          </a:prstGeom>
+          <a:noFill/>
+        </p:spPr>
+        <p:txBody>
+          <a:bodyPr wrap="square" anchor="t" lIns="45720" rIns="45720">
+            <a:spAutoFit/>
+          </a:bodyPr>
+          <a:lstStyle/>
+          <a:p>
+            <a:pPr algn="l">
+              <a:spcAft>
+                <a:spcPts val="1080"/>
+              </a:spcAft>
+            </a:pPr>
+            <a:r>
+              <a:rPr sz="1800" b="0">
+                <a:solidFill>
+                  <a:srgbClr val="111111"/>
+                </a:solidFill>
+                <a:latin typeface="Calibri"/>
+              </a:rPr>
+              <a:t>4. Die Liste zeigt die Bewerber. Jede angehakte Zeile trägt den Chip </a:t>
+            </a:r>
+            <a:r>
+              <a:rPr sz="1800" b="1">
+                <a:solidFill>
+                  <a:srgbClr val="111111"/>
+                </a:solidFill>
+                <a:latin typeface="Calibri"/>
+              </a:rPr>
+              <a:t>„bekommt: Termine ansehen“</a:t>
+            </a:r>
+            <a:r>
+              <a:rPr sz="1800" b="0">
+                <a:solidFill>
+                  <a:srgbClr val="111111"/>
+                </a:solidFill>
+                <a:latin typeface="Calibri"/>
+              </a:rPr>
+              <a:t>. Wer nicht angeschrieben werden soll: Haken raus. Graue Zeilen sind gesperrt, der Grund steht daneben.</a:t>
+            </a:r>
+          </a:p>
+          <a:p>
+            <a:pPr algn="l">
+              <a:spcAft>
+                <a:spcPts val="1080"/>
+              </a:spcAft>
+            </a:pPr>
+            <a:r>
+              <a:rPr sz="1800" b="0">
+                <a:solidFill>
+                  <a:srgbClr val="111111"/>
+                </a:solidFill>
+                <a:latin typeface="Calibri"/>
+              </a:rPr>
+              <a:t>5. Unten steht die Nachricht so, wie der Bewerber sie liest, mit „Anna“ als Beispielname. Beim Versand steht dort der echte Vorname. Über </a:t>
+            </a:r>
+            <a:r>
+              <a:rPr sz="1800" b="1">
+                <a:solidFill>
+                  <a:srgbClr val="111111"/>
+                </a:solidFill>
+                <a:latin typeface="Calibri"/>
+              </a:rPr>
+              <a:t>„Vorlage ändern“</a:t>
+            </a:r>
+            <a:r>
+              <a:rPr sz="1800" b="0">
+                <a:solidFill>
+                  <a:srgbClr val="111111"/>
+                </a:solidFill>
+                <a:latin typeface="Calibri"/>
+              </a:rPr>
+              <a:t> wählt ihr eine andere Vorlage.</a:t>
+            </a:r>
+          </a:p>
+        </p:txBody>
+      </p:sp>
+      <p:sp>
+        <p:nvSpPr>
+          <p:cNvPr id="9" name="TextBox 8"/>
+          <p:cNvSpPr txBox="1"/>
+          <p:nvPr/>
+        </p:nvSpPr>
+        <p:spPr>
+          <a:xfrm>
+            <a:off x="6263640" y="1773936"/>
+            <a:ext cx="5212080" cy="3621024"/>
+          </a:xfrm>
+          <a:prstGeom prst="rect">
+            <a:avLst/>
+          </a:prstGeom>
+          <a:noFill/>
+        </p:spPr>
+        <p:txBody>
+          <a:bodyPr wrap="square" anchor="t" lIns="45720" rIns="45720">
+            <a:spAutoFit/>
+          </a:bodyPr>
+          <a:lstStyle/>
+          <a:p>
+            <a:pPr algn="l">
+              <a:spcAft>
+                <a:spcPts val="1080"/>
+              </a:spcAft>
+            </a:pPr>
+            <a:r>
+              <a:rPr sz="1800" b="0">
+                <a:solidFill>
+                  <a:srgbClr val="111111"/>
+                </a:solidFill>
+                <a:latin typeface="Calibri"/>
+              </a:rPr>
+              <a:t>6. Auf </a:t>
+            </a:r>
+            <a:r>
+              <a:rPr sz="1800" b="1">
+                <a:solidFill>
+                  <a:srgbClr val="111111"/>
+                </a:solidFill>
+                <a:latin typeface="Calibri"/>
+              </a:rPr>
+              <a:t>„WhatsApp an N Personen senden“</a:t>
+            </a:r>
+            <a:r>
+              <a:rPr sz="1800" b="0">
+                <a:solidFill>
+                  <a:srgbClr val="111111"/>
+                </a:solidFill>
+                <a:latin typeface="Calibri"/>
+              </a:rPr>
+              <a:t> klicken und die Nachfrage bestätigen. Der Fortschritt läuft im Fenster mit.</a:t>
+            </a:r>
+          </a:p>
+        </p:txBody>
+      </p:sp>
+      <p:sp>
+        <p:nvSpPr>
+          <p:cNvPr id="10" name="TextBox 9"/>
+          <p:cNvSpPr txBox="1"/>
+          <p:nvPr/>
+        </p:nvSpPr>
+        <p:spPr>
+          <a:xfrm>
+            <a:off x="685800" y="5486400"/>
             <a:ext cx="10789920" cy="731520"/>
           </a:xfrm>
           <a:prstGeom prst="rect">
@@ -5138,236 +5396,13 @@
               </a:spcAft>
             </a:pPr>
             <a:r>
-              <a:rPr sz="1600" b="0">
-                <a:solidFill>
-                  <a:srgbClr val="5F6368"/>
-                </a:solidFill>
-                <a:latin typeface="Calibri"/>
-              </a:rPr>
-              <a:t>Ist ein kommender Termin ausgebucht, schreibt ihr mit einem Klick alle Bewerber dieser Ausschreibung ohne Termin an. Sie bekommen eine WhatsApp mit dem Link zur Terminauswahl und buchen sich selbst in einen anderen Termin.</a:t>
-            </a:r>
-          </a:p>
-        </p:txBody>
-      </p:sp>
-      <p:sp>
-        <p:nvSpPr>
-          <p:cNvPr id="9" name="TextBox 8"/>
-          <p:cNvSpPr txBox="1"/>
-          <p:nvPr/>
-        </p:nvSpPr>
-        <p:spPr>
-          <a:xfrm>
-            <a:off x="685800" y="2514600"/>
-            <a:ext cx="5212080" cy="2880360"/>
-          </a:xfrm>
-          <a:prstGeom prst="rect">
-            <a:avLst/>
-          </a:prstGeom>
-          <a:noFill/>
-        </p:spPr>
-        <p:txBody>
-          <a:bodyPr wrap="square" anchor="t" lIns="45720" rIns="45720">
-            <a:spAutoFit/>
-          </a:bodyPr>
-          <a:lstStyle/>
-          <a:p>
-            <a:pPr algn="l">
-              <a:spcAft>
-                <a:spcPts val="1080"/>
-              </a:spcAft>
-            </a:pPr>
-            <a:r>
-              <a:rPr sz="1800" b="0">
-                <a:solidFill>
-                  <a:srgbClr val="111111"/>
-                </a:solidFill>
-                <a:latin typeface="Calibri"/>
-              </a:rPr>
-              <a:t>1. </a:t>
-            </a:r>
-            <a:r>
-              <a:rPr sz="1800" b="1">
-                <a:solidFill>
-                  <a:srgbClr val="111111"/>
-                </a:solidFill>
-                <a:latin typeface="Calibri"/>
-              </a:rPr>
-              <a:t>Statistik</a:t>
-            </a:r>
-            <a:r>
-              <a:rPr sz="1800" b="0">
-                <a:solidFill>
-                  <a:srgbClr val="111111"/>
-                </a:solidFill>
-                <a:latin typeface="Calibri"/>
-              </a:rPr>
-              <a:t> öffnen, Filiale wählen, nach unten zur Tabelle </a:t>
-            </a:r>
-            <a:r>
-              <a:rPr sz="1800" b="1">
-                <a:solidFill>
-                  <a:srgbClr val="111111"/>
-                </a:solidFill>
-                <a:latin typeface="Calibri"/>
-              </a:rPr>
-              <a:t>„Schulungstermine“</a:t>
-            </a:r>
-            <a:r>
-              <a:rPr sz="1800" b="0">
-                <a:solidFill>
-                  <a:srgbClr val="111111"/>
-                </a:solidFill>
-                <a:latin typeface="Calibri"/>
-              </a:rPr>
-              <a:t> scrollen.</a:t>
-            </a:r>
-          </a:p>
-          <a:p>
-            <a:pPr algn="l">
-              <a:spcAft>
-                <a:spcPts val="1080"/>
-              </a:spcAft>
-            </a:pPr>
-            <a:r>
-              <a:rPr sz="1800" b="0">
-                <a:solidFill>
-                  <a:srgbClr val="111111"/>
-                </a:solidFill>
-                <a:latin typeface="Calibri"/>
-              </a:rPr>
-              <a:t>2. Am vollen Termin steht in der Spalte Ausschreibung das Badge </a:t>
-            </a:r>
-            <a:r>
-              <a:rPr sz="1800" b="1">
-                <a:solidFill>
-                  <a:srgbClr val="111111"/>
-                </a:solidFill>
-                <a:latin typeface="Calibri"/>
-              </a:rPr>
-              <a:t>„Ausgebucht“</a:t>
-            </a:r>
-            <a:r>
-              <a:rPr sz="1800" b="0">
-                <a:solidFill>
-                  <a:srgbClr val="111111"/>
-                </a:solidFill>
-                <a:latin typeface="Calibri"/>
-              </a:rPr>
-              <a:t> und daneben die Pille </a:t>
-            </a:r>
-            <a:r>
-              <a:rPr sz="1800" b="1">
-                <a:solidFill>
-                  <a:srgbClr val="111111"/>
-                </a:solidFill>
-                <a:latin typeface="Calibri"/>
-              </a:rPr>
-              <a:t>„N ohne Termin“</a:t>
-            </a:r>
-            <a:r>
-              <a:rPr sz="1800" b="0">
-                <a:solidFill>
-                  <a:srgbClr val="111111"/>
-                </a:solidFill>
-                <a:latin typeface="Calibri"/>
-              </a:rPr>
-              <a:t>. Auf die Pille klicken.</a:t>
-            </a:r>
-          </a:p>
-        </p:txBody>
-      </p:sp>
-      <p:sp>
-        <p:nvSpPr>
-          <p:cNvPr id="10" name="TextBox 9"/>
-          <p:cNvSpPr txBox="1"/>
-          <p:nvPr/>
-        </p:nvSpPr>
-        <p:spPr>
-          <a:xfrm>
-            <a:off x="6263640" y="2514600"/>
-            <a:ext cx="5212080" cy="2880360"/>
-          </a:xfrm>
-          <a:prstGeom prst="rect">
-            <a:avLst/>
-          </a:prstGeom>
-          <a:noFill/>
-        </p:spPr>
-        <p:txBody>
-          <a:bodyPr wrap="square" anchor="t" lIns="45720" rIns="45720">
-            <a:spAutoFit/>
-          </a:bodyPr>
-          <a:lstStyle/>
-          <a:p>
-            <a:pPr algn="l">
-              <a:spcAft>
-                <a:spcPts val="1080"/>
-              </a:spcAft>
-            </a:pPr>
-            <a:r>
-              <a:rPr sz="1800" b="0">
-                <a:solidFill>
-                  <a:srgbClr val="111111"/>
-                </a:solidFill>
-                <a:latin typeface="Calibri"/>
-              </a:rPr>
-              <a:t>3. Oben im Fenster steht der Anlass: welcher Termin voll ist und wie viele weitere Termine mit freien Plätzen es an dieser Stelle gibt. </a:t>
-            </a:r>
-            <a:r>
-              <a:rPr sz="1800" b="1">
-                <a:solidFill>
-                  <a:srgbClr val="111111"/>
-                </a:solidFill>
-                <a:latin typeface="Calibri"/>
-              </a:rPr>
-              <a:t>Ist die Karte rot, gibt es keine Alternative.</a:t>
-            </a:r>
-            <a:r>
-              <a:rPr sz="1800" b="0">
-                <a:solidFill>
-                  <a:srgbClr val="111111"/>
-                </a:solidFill>
-                <a:latin typeface="Calibri"/>
-              </a:rPr>
-              <a:t> Dann erst einen neuen Termin anlegen.</a:t>
-            </a:r>
-          </a:p>
-        </p:txBody>
-      </p:sp>
-      <p:sp>
-        <p:nvSpPr>
-          <p:cNvPr id="11" name="TextBox 10"/>
-          <p:cNvSpPr txBox="1"/>
-          <p:nvPr/>
-        </p:nvSpPr>
-        <p:spPr>
-          <a:xfrm>
-            <a:off x="685800" y="5486400"/>
-            <a:ext cx="10789920" cy="731520"/>
-          </a:xfrm>
-          <a:prstGeom prst="rect">
-            <a:avLst/>
-          </a:prstGeom>
-          <a:noFill/>
-        </p:spPr>
-        <p:txBody>
-          <a:bodyPr wrap="square" anchor="t" lIns="45720" rIns="45720">
-            <a:spAutoFit/>
-          </a:bodyPr>
-          <a:lstStyle/>
-          <a:p>
-            <a:pPr algn="l">
-              <a:spcAft>
-                <a:spcPts val="960"/>
-              </a:spcAft>
-            </a:pPr>
-            <a:r>
-              <a:rPr sz="1600" b="0">
-                <a:solidFill>
-                  <a:srgbClr val="5F6368"/>
-                </a:solidFill>
-                <a:latin typeface="Calibri"/>
-              </a:rPr>
-              <a:t>Die Pille erscheint nur bei Platzzahl, voll belegt, künftigem Termin und hinterlegter Ausschreibung. Fehlt die Ausschreibung, steht nur das Badge mit „keine Ausschreibung“.</a:t>
+              <a:rPr sz="1600" b="1">
+                <a:solidFill>
+                  <a:srgbClr val="1273DE"/>
+                </a:solidFill>
+                <a:latin typeface="Calibri"/>
+              </a:rPr>
+              <a:t>Die Bewerber buchen sich danach selbst in einen freien Termin.</a:t>
             </a:r>
           </a:p>
         </p:txBody>
@@ -5467,7 +5502,7 @@
                 </a:solidFill>
                 <a:latin typeface="Calibri"/>
               </a:rPr>
-              <a:t>WENN EINE SCHULUNG VOLL IST · SCHRITT 2</a:t>
+              <a:t>GUT ZU WISSEN · TEILNEHMER VERSCHIEBEN</a:t>
             </a:r>
           </a:p>
         </p:txBody>
@@ -5506,7 +5541,7 @@
                 </a:solidFill>
                 <a:latin typeface="Calibri"/>
               </a:rPr>
-              <a:t>Empfänger prüfen und senden</a:t>
+              <a:t>Regeln auf einen Blick</a:t>
             </a:r>
           </a:p>
         </p:txBody>
@@ -5632,942 +5667,6 @@
           </a:p>
         </p:txBody>
       </p:sp>
-      <p:sp>
-        <p:nvSpPr>
-          <p:cNvPr id="8" name="TextBox 7"/>
-          <p:cNvSpPr txBox="1"/>
-          <p:nvPr/>
-        </p:nvSpPr>
-        <p:spPr>
-          <a:xfrm>
-            <a:off x="685800" y="1773936"/>
-            <a:ext cx="5212080" cy="3621024"/>
-          </a:xfrm>
-          <a:prstGeom prst="rect">
-            <a:avLst/>
-          </a:prstGeom>
-          <a:noFill/>
-        </p:spPr>
-        <p:txBody>
-          <a:bodyPr wrap="square" anchor="t" lIns="45720" rIns="45720">
-            <a:spAutoFit/>
-          </a:bodyPr>
-          <a:lstStyle/>
-          <a:p>
-            <a:pPr algn="l">
-              <a:spcAft>
-                <a:spcPts val="1080"/>
-              </a:spcAft>
-            </a:pPr>
-            <a:r>
-              <a:rPr sz="1800" b="0">
-                <a:solidFill>
-                  <a:srgbClr val="111111"/>
-                </a:solidFill>
-                <a:latin typeface="Calibri"/>
-              </a:rPr>
-              <a:t>4. Die Liste zeigt die Bewerber. Jede angehakte Zeile trägt den Chip </a:t>
-            </a:r>
-            <a:r>
-              <a:rPr sz="1800" b="1">
-                <a:solidFill>
-                  <a:srgbClr val="111111"/>
-                </a:solidFill>
-                <a:latin typeface="Calibri"/>
-              </a:rPr>
-              <a:t>„bekommt: Termine ansehen“</a:t>
-            </a:r>
-            <a:r>
-              <a:rPr sz="1800" b="0">
-                <a:solidFill>
-                  <a:srgbClr val="111111"/>
-                </a:solidFill>
-                <a:latin typeface="Calibri"/>
-              </a:rPr>
-              <a:t>. Wer nicht angeschrieben werden soll: Haken raus. Graue Zeilen sind gesperrt, der Grund steht daneben.</a:t>
-            </a:r>
-          </a:p>
-          <a:p>
-            <a:pPr algn="l">
-              <a:spcAft>
-                <a:spcPts val="1080"/>
-              </a:spcAft>
-            </a:pPr>
-            <a:r>
-              <a:rPr sz="1800" b="0">
-                <a:solidFill>
-                  <a:srgbClr val="111111"/>
-                </a:solidFill>
-                <a:latin typeface="Calibri"/>
-              </a:rPr>
-              <a:t>5. Unten steht die Nachricht so, wie der Bewerber sie liest, mit „Anna“ als Beispielname. Beim Versand steht dort der echte Vorname. Über </a:t>
-            </a:r>
-            <a:r>
-              <a:rPr sz="1800" b="1">
-                <a:solidFill>
-                  <a:srgbClr val="111111"/>
-                </a:solidFill>
-                <a:latin typeface="Calibri"/>
-              </a:rPr>
-              <a:t>„Vorlage ändern“</a:t>
-            </a:r>
-            <a:r>
-              <a:rPr sz="1800" b="0">
-                <a:solidFill>
-                  <a:srgbClr val="111111"/>
-                </a:solidFill>
-                <a:latin typeface="Calibri"/>
-              </a:rPr>
-              <a:t> wählt ihr eine andere Vorlage.</a:t>
-            </a:r>
-          </a:p>
-        </p:txBody>
-      </p:sp>
-      <p:sp>
-        <p:nvSpPr>
-          <p:cNvPr id="9" name="TextBox 8"/>
-          <p:cNvSpPr txBox="1"/>
-          <p:nvPr/>
-        </p:nvSpPr>
-        <p:spPr>
-          <a:xfrm>
-            <a:off x="6263640" y="1773936"/>
-            <a:ext cx="5212080" cy="3621024"/>
-          </a:xfrm>
-          <a:prstGeom prst="rect">
-            <a:avLst/>
-          </a:prstGeom>
-          <a:noFill/>
-        </p:spPr>
-        <p:txBody>
-          <a:bodyPr wrap="square" anchor="t" lIns="45720" rIns="45720">
-            <a:spAutoFit/>
-          </a:bodyPr>
-          <a:lstStyle/>
-          <a:p>
-            <a:pPr algn="l">
-              <a:spcAft>
-                <a:spcPts val="1080"/>
-              </a:spcAft>
-            </a:pPr>
-            <a:r>
-              <a:rPr sz="1800" b="0">
-                <a:solidFill>
-                  <a:srgbClr val="111111"/>
-                </a:solidFill>
-                <a:latin typeface="Calibri"/>
-              </a:rPr>
-              <a:t>6. Auf </a:t>
-            </a:r>
-            <a:r>
-              <a:rPr sz="1800" b="1">
-                <a:solidFill>
-                  <a:srgbClr val="111111"/>
-                </a:solidFill>
-                <a:latin typeface="Calibri"/>
-              </a:rPr>
-              <a:t>„WhatsApp an N Personen senden“</a:t>
-            </a:r>
-            <a:r>
-              <a:rPr sz="1800" b="0">
-                <a:solidFill>
-                  <a:srgbClr val="111111"/>
-                </a:solidFill>
-                <a:latin typeface="Calibri"/>
-              </a:rPr>
-              <a:t> klicken und die Nachfrage bestätigen. Der Fortschritt läuft im Fenster mit.</a:t>
-            </a:r>
-          </a:p>
-        </p:txBody>
-      </p:sp>
-      <p:sp>
-        <p:nvSpPr>
-          <p:cNvPr id="10" name="TextBox 9"/>
-          <p:cNvSpPr txBox="1"/>
-          <p:nvPr/>
-        </p:nvSpPr>
-        <p:spPr>
-          <a:xfrm>
-            <a:off x="685800" y="5486400"/>
-            <a:ext cx="10789920" cy="731520"/>
-          </a:xfrm>
-          <a:prstGeom prst="rect">
-            <a:avLst/>
-          </a:prstGeom>
-          <a:noFill/>
-        </p:spPr>
-        <p:txBody>
-          <a:bodyPr wrap="square" anchor="t" lIns="45720" rIns="45720">
-            <a:spAutoFit/>
-          </a:bodyPr>
-          <a:lstStyle/>
-          <a:p>
-            <a:pPr algn="l">
-              <a:spcAft>
-                <a:spcPts val="960"/>
-              </a:spcAft>
-            </a:pPr>
-            <a:r>
-              <a:rPr sz="1600" b="1">
-                <a:solidFill>
-                  <a:srgbClr val="1273DE"/>
-                </a:solidFill>
-                <a:latin typeface="Calibri"/>
-              </a:rPr>
-              <a:t>Die Bewerber buchen sich danach selbst in einen freien Termin.</a:t>
-            </a:r>
-          </a:p>
-        </p:txBody>
-      </p:sp>
-    </p:spTree>
-  </p:cSld>
-  <p:clrMapOvr>
-    <a:masterClrMapping/>
-  </p:clrMapOvr>
-</p:sld>
-</file>
-
-<file path=ppt/slides/slide7.xml><?xml version="1.0" encoding="utf-8"?>
-<p:sld xmlns:a="http://schemas.openxmlformats.org/drawingml/2006/main" xmlns:p="http://schemas.openxmlformats.org/presentationml/2006/main" xmlns:r="http://schemas.openxmlformats.org/officeDocument/2006/relationships">
-  <p:cSld>
-    <p:spTree>
-      <p:nvGrpSpPr>
-        <p:cNvPr id="1" name=""/>
-        <p:cNvGrpSpPr/>
-        <p:nvPr/>
-      </p:nvGrpSpPr>
-      <p:grpSpPr/>
-      <p:sp>
-        <p:nvSpPr>
-          <p:cNvPr id="2" name="Rectangle 1"/>
-          <p:cNvSpPr/>
-          <p:nvPr/>
-        </p:nvSpPr>
-        <p:spPr>
-          <a:xfrm>
-            <a:off x="0" y="0"/>
-            <a:ext cx="155448" cy="6858000"/>
-          </a:xfrm>
-          <a:prstGeom prst="rect">
-            <a:avLst/>
-          </a:prstGeom>
-          <a:solidFill>
-            <a:srgbClr val="1273DE"/>
-          </a:solidFill>
-          <a:ln>
-            <a:noFill/>
-          </a:ln>
-        </p:spPr>
-        <p:style>
-          <a:lnRef idx="1">
-            <a:schemeClr val="accent1"/>
-          </a:lnRef>
-          <a:fillRef idx="3">
-            <a:schemeClr val="accent1"/>
-          </a:fillRef>
-          <a:effectRef idx="2">
-            <a:schemeClr val="accent1"/>
-          </a:effectRef>
-          <a:fontRef idx="minor">
-            <a:schemeClr val="lt1"/>
-          </a:fontRef>
-        </p:style>
-        <p:txBody>
-          <a:bodyPr rtlCol="0" anchor="ctr"/>
-          <a:lstStyle/>
-          <a:p>
-            <a:pPr algn="ctr"/>
-          </a:p>
-        </p:txBody>
-      </p:sp>
-      <p:sp>
-        <p:nvSpPr>
-          <p:cNvPr id="3" name="TextBox 2"/>
-          <p:cNvSpPr txBox="1"/>
-          <p:nvPr/>
-        </p:nvSpPr>
-        <p:spPr>
-          <a:xfrm>
-            <a:off x="612648" y="329184"/>
-            <a:ext cx="10479024" cy="274320"/>
-          </a:xfrm>
-          <a:prstGeom prst="rect">
-            <a:avLst/>
-          </a:prstGeom>
-          <a:noFill/>
-        </p:spPr>
-        <p:txBody>
-          <a:bodyPr wrap="square" anchor="t" lIns="45720" rIns="45720">
-            <a:spAutoFit/>
-          </a:bodyPr>
-          <a:lstStyle/>
-          <a:p>
-            <a:pPr algn="l">
-              <a:spcAft>
-                <a:spcPts val="719"/>
-              </a:spcAft>
-            </a:pPr>
-            <a:r>
-              <a:rPr sz="1200" b="1">
-                <a:solidFill>
-                  <a:srgbClr val="1273DE"/>
-                </a:solidFill>
-                <a:latin typeface="Calibri"/>
-              </a:rPr>
-              <a:t>NEU · NACH DER SCHULUNG</a:t>
-            </a:r>
-          </a:p>
-        </p:txBody>
-      </p:sp>
-      <p:sp>
-        <p:nvSpPr>
-          <p:cNvPr id="4" name="TextBox 3"/>
-          <p:cNvSpPr txBox="1"/>
-          <p:nvPr/>
-        </p:nvSpPr>
-        <p:spPr>
-          <a:xfrm>
-            <a:off x="612648" y="731520"/>
-            <a:ext cx="10936224" cy="640080"/>
-          </a:xfrm>
-          <a:prstGeom prst="rect">
-            <a:avLst/>
-          </a:prstGeom>
-          <a:noFill/>
-        </p:spPr>
-        <p:txBody>
-          <a:bodyPr wrap="square" anchor="t" lIns="45720" rIns="45720">
-            <a:spAutoFit/>
-          </a:bodyPr>
-          <a:lstStyle/>
-          <a:p>
-            <a:pPr algn="l">
-              <a:spcAft>
-                <a:spcPts val="1709"/>
-              </a:spcAft>
-            </a:pPr>
-            <a:r>
-              <a:rPr sz="2850" b="1">
-                <a:solidFill>
-                  <a:srgbClr val="111111"/>
-                </a:solidFill>
-                <a:latin typeface="Calibri"/>
-              </a:rPr>
-              <a:t>Vertragsdaten eintragen, auch zu zweit</a:t>
-            </a:r>
-          </a:p>
-        </p:txBody>
-      </p:sp>
-      <p:sp>
-        <p:nvSpPr>
-          <p:cNvPr id="5" name="Rectangle 4"/>
-          <p:cNvSpPr/>
-          <p:nvPr/>
-        </p:nvSpPr>
-        <p:spPr>
-          <a:xfrm>
-            <a:off x="512064" y="1435608"/>
-            <a:ext cx="11128248" cy="9144"/>
-          </a:xfrm>
-          <a:prstGeom prst="rect">
-            <a:avLst/>
-          </a:prstGeom>
-          <a:solidFill>
-            <a:srgbClr val="B8BCC4"/>
-          </a:solidFill>
-          <a:ln>
-            <a:noFill/>
-          </a:ln>
-        </p:spPr>
-        <p:style>
-          <a:lnRef idx="1">
-            <a:schemeClr val="accent1"/>
-          </a:lnRef>
-          <a:fillRef idx="3">
-            <a:schemeClr val="accent1"/>
-          </a:fillRef>
-          <a:effectRef idx="2">
-            <a:schemeClr val="accent1"/>
-          </a:effectRef>
-          <a:fontRef idx="minor">
-            <a:schemeClr val="lt1"/>
-          </a:fontRef>
-        </p:style>
-        <p:txBody>
-          <a:bodyPr rtlCol="0" anchor="ctr"/>
-          <a:lstStyle/>
-          <a:p>
-            <a:pPr algn="ctr"/>
-          </a:p>
-        </p:txBody>
-      </p:sp>
-      <p:sp>
-        <p:nvSpPr>
-          <p:cNvPr id="6" name="TextBox 5"/>
-          <p:cNvSpPr txBox="1"/>
-          <p:nvPr/>
-        </p:nvSpPr>
-        <p:spPr>
-          <a:xfrm>
-            <a:off x="612648" y="6419088"/>
-            <a:ext cx="6190488" cy="274320"/>
-          </a:xfrm>
-          <a:prstGeom prst="rect">
-            <a:avLst/>
-          </a:prstGeom>
-          <a:noFill/>
-        </p:spPr>
-        <p:txBody>
-          <a:bodyPr wrap="square" anchor="t" lIns="45720" rIns="45720">
-            <a:spAutoFit/>
-          </a:bodyPr>
-          <a:lstStyle/>
-          <a:p>
-            <a:pPr algn="l">
-              <a:spcAft>
-                <a:spcPts val="630"/>
-              </a:spcAft>
-            </a:pPr>
-            <a:r>
-              <a:rPr sz="1050" b="0">
-                <a:solidFill>
-                  <a:srgbClr val="5F6368"/>
-                </a:solidFill>
-                <a:latin typeface="Calibri"/>
-              </a:rPr>
-              <a:t>RheinGedeck · Intern</a:t>
-            </a:r>
-          </a:p>
-        </p:txBody>
-      </p:sp>
-      <p:sp>
-        <p:nvSpPr>
-          <p:cNvPr id="7" name="TextBox 6"/>
-          <p:cNvSpPr txBox="1"/>
-          <p:nvPr/>
-        </p:nvSpPr>
-        <p:spPr>
-          <a:xfrm>
-            <a:off x="11009376" y="6419088"/>
-            <a:ext cx="530352" cy="274320"/>
-          </a:xfrm>
-          <a:prstGeom prst="rect">
-            <a:avLst/>
-          </a:prstGeom>
-          <a:noFill/>
-        </p:spPr>
-        <p:txBody>
-          <a:bodyPr wrap="square" anchor="t" lIns="45720" rIns="45720">
-            <a:spAutoFit/>
-          </a:bodyPr>
-          <a:lstStyle/>
-          <a:p>
-            <a:pPr algn="r">
-              <a:spcAft>
-                <a:spcPts val="630"/>
-              </a:spcAft>
-            </a:pPr>
-            <a:r>
-              <a:rPr sz="1050" b="0">
-                <a:solidFill>
-                  <a:srgbClr val="5F6368"/>
-                </a:solidFill>
-                <a:latin typeface="Calibri"/>
-              </a:rPr>
-              <a:t>07</a:t>
-            </a:r>
-          </a:p>
-        </p:txBody>
-      </p:sp>
-      <p:sp>
-        <p:nvSpPr>
-          <p:cNvPr id="8" name="TextBox 7"/>
-          <p:cNvSpPr txBox="1"/>
-          <p:nvPr/>
-        </p:nvSpPr>
-        <p:spPr>
-          <a:xfrm>
-            <a:off x="685800" y="1773936"/>
-            <a:ext cx="3291840" cy="3657600"/>
-          </a:xfrm>
-          <a:prstGeom prst="rect">
-            <a:avLst/>
-          </a:prstGeom>
-          <a:noFill/>
-        </p:spPr>
-        <p:txBody>
-          <a:bodyPr wrap="square" anchor="t" lIns="45720" rIns="45720">
-            <a:spAutoFit/>
-          </a:bodyPr>
-          <a:lstStyle/>
-          <a:p>
-            <a:pPr algn="l">
-              <a:spcAft>
-                <a:spcPts val="1019"/>
-              </a:spcAft>
-            </a:pPr>
-            <a:r>
-              <a:rPr sz="1700" b="0">
-                <a:solidFill>
-                  <a:srgbClr val="111111"/>
-                </a:solidFill>
-                <a:latin typeface="Calibri"/>
-              </a:rPr>
-              <a:t>1. Den Termin öffnen, Reiter </a:t>
-            </a:r>
-            <a:r>
-              <a:rPr sz="1700" b="1">
-                <a:solidFill>
-                  <a:srgbClr val="111111"/>
-                </a:solidFill>
-                <a:latin typeface="Calibri"/>
-              </a:rPr>
-              <a:t>„Nach der Schulung“</a:t>
-            </a:r>
-            <a:r>
-              <a:rPr sz="1700" b="0">
-                <a:solidFill>
-                  <a:srgbClr val="111111"/>
-                </a:solidFill>
-                <a:latin typeface="Calibri"/>
-              </a:rPr>
-              <a:t>.</a:t>
-            </a:r>
-          </a:p>
-          <a:p>
-            <a:pPr algn="l">
-              <a:spcAft>
-                <a:spcPts val="1019"/>
-              </a:spcAft>
-            </a:pPr>
-            <a:r>
-              <a:rPr sz="1700" b="0">
-                <a:solidFill>
-                  <a:srgbClr val="111111"/>
-                </a:solidFill>
-                <a:latin typeface="Calibri"/>
-              </a:rPr>
-              <a:t>2. </a:t>
-            </a:r>
-            <a:r>
-              <a:rPr sz="1700" b="1">
-                <a:solidFill>
-                  <a:srgbClr val="111111"/>
-                </a:solidFill>
-                <a:latin typeface="Calibri"/>
-              </a:rPr>
-              <a:t>Zuschlag</a:t>
-            </a:r>
-            <a:r>
-              <a:rPr sz="1700" b="0">
-                <a:solidFill>
-                  <a:srgbClr val="111111"/>
-                </a:solidFill>
-                <a:latin typeface="Calibri"/>
-              </a:rPr>
-              <a:t>, </a:t>
-            </a:r>
-            <a:r>
-              <a:rPr sz="1700" b="1">
-                <a:solidFill>
-                  <a:srgbClr val="111111"/>
-                </a:solidFill>
-                <a:latin typeface="Calibri"/>
-              </a:rPr>
-              <a:t>Vertragsbeginn</a:t>
-            </a:r>
-            <a:r>
-              <a:rPr sz="1700" b="0">
-                <a:solidFill>
-                  <a:srgbClr val="111111"/>
-                </a:solidFill>
-                <a:latin typeface="Calibri"/>
-              </a:rPr>
-              <a:t> und bei Bedarf </a:t>
-            </a:r>
-            <a:r>
-              <a:rPr sz="1700" b="1">
-                <a:solidFill>
-                  <a:srgbClr val="111111"/>
-                </a:solidFill>
-                <a:latin typeface="Calibri"/>
-              </a:rPr>
-              <a:t>Vertragsende</a:t>
-            </a:r>
-            <a:r>
-              <a:rPr sz="1700" b="0">
-                <a:solidFill>
-                  <a:srgbClr val="111111"/>
-                </a:solidFill>
-                <a:latin typeface="Calibri"/>
-              </a:rPr>
-              <a:t> eintragen. Ohne Ende rechnet das System es aus.</a:t>
-            </a:r>
-          </a:p>
-          <a:p>
-            <a:pPr algn="l">
-              <a:spcAft>
-                <a:spcPts val="1019"/>
-              </a:spcAft>
-            </a:pPr>
-            <a:r>
-              <a:rPr sz="1700" b="0">
-                <a:solidFill>
-                  <a:srgbClr val="111111"/>
-                </a:solidFill>
-                <a:latin typeface="Calibri"/>
-              </a:rPr>
-              <a:t>3. Zum Schluss die Verträge über den </a:t>
-            </a:r>
-            <a:r>
-              <a:rPr sz="1700" b="1">
-                <a:solidFill>
-                  <a:srgbClr val="111111"/>
-                </a:solidFill>
-                <a:latin typeface="Calibri"/>
-              </a:rPr>
-              <a:t>Sammelversand</a:t>
-            </a:r>
-            <a:r>
-              <a:rPr sz="1700" b="0">
-                <a:solidFill>
-                  <a:srgbClr val="111111"/>
-                </a:solidFill>
-                <a:latin typeface="Calibri"/>
-              </a:rPr>
-              <a:t> schicken.</a:t>
-            </a:r>
-          </a:p>
-        </p:txBody>
-      </p:sp>
-      <p:sp>
-        <p:nvSpPr>
-          <p:cNvPr id="9" name="TextBox 8"/>
-          <p:cNvSpPr txBox="1"/>
-          <p:nvPr/>
-        </p:nvSpPr>
-        <p:spPr>
-          <a:xfrm>
-            <a:off x="685800" y="5257800"/>
-            <a:ext cx="3291840" cy="1005840"/>
-          </a:xfrm>
-          <a:prstGeom prst="rect">
-            <a:avLst/>
-          </a:prstGeom>
-          <a:noFill/>
-        </p:spPr>
-        <p:txBody>
-          <a:bodyPr wrap="square" anchor="t" lIns="45720" rIns="45720">
-            <a:spAutoFit/>
-          </a:bodyPr>
-          <a:lstStyle/>
-          <a:p>
-            <a:pPr algn="l">
-              <a:spcAft>
-                <a:spcPts val="960"/>
-              </a:spcAft>
-            </a:pPr>
-            <a:r>
-              <a:rPr sz="1600" b="1">
-                <a:solidFill>
-                  <a:srgbClr val="1273DE"/>
-                </a:solidFill>
-                <a:latin typeface="Calibri"/>
-              </a:rPr>
-              <a:t>Jede Eingabe ist sofort gespeichert. Zwei Laptops sehen denselben Stand.</a:t>
-            </a:r>
-          </a:p>
-        </p:txBody>
-      </p:sp>
-      <p:pic>
-        <p:nvPicPr>
-          <p:cNvPr id="10" name="Picture 9" descr="D_nach_der_schulung.png"/>
-          <p:cNvPicPr>
-            <a:picLocks noChangeAspect="1"/>
-          </p:cNvPicPr>
-          <p:nvPr/>
-        </p:nvPicPr>
-        <p:blipFill>
-          <a:blip r:embed="rId2"/>
-          <a:stretch>
-            <a:fillRect/>
-          </a:stretch>
-        </p:blipFill>
-        <p:spPr>
-          <a:xfrm>
-            <a:off x="4160520" y="2178763"/>
-            <a:ext cx="7360920" cy="3597753"/>
-          </a:xfrm>
-          <a:prstGeom prst="rect">
-            <a:avLst/>
-          </a:prstGeom>
-          <a:ln w="9525">
-            <a:solidFill>
-              <a:srgbClr val="B8BCC4"/>
-            </a:solidFill>
-          </a:ln>
-        </p:spPr>
-      </p:pic>
-    </p:spTree>
-  </p:cSld>
-  <p:clrMapOvr>
-    <a:masterClrMapping/>
-  </p:clrMapOvr>
-</p:sld>
-</file>
-
-<file path=ppt/slides/slide8.xml><?xml version="1.0" encoding="utf-8"?>
-<p:sld xmlns:a="http://schemas.openxmlformats.org/drawingml/2006/main" xmlns:p="http://schemas.openxmlformats.org/presentationml/2006/main" xmlns:r="http://schemas.openxmlformats.org/officeDocument/2006/relationships">
-  <p:cSld>
-    <p:spTree>
-      <p:nvGrpSpPr>
-        <p:cNvPr id="1" name=""/>
-        <p:cNvGrpSpPr/>
-        <p:nvPr/>
-      </p:nvGrpSpPr>
-      <p:grpSpPr/>
-      <p:sp>
-        <p:nvSpPr>
-          <p:cNvPr id="2" name="Rectangle 1"/>
-          <p:cNvSpPr/>
-          <p:nvPr/>
-        </p:nvSpPr>
-        <p:spPr>
-          <a:xfrm>
-            <a:off x="0" y="0"/>
-            <a:ext cx="155448" cy="6858000"/>
-          </a:xfrm>
-          <a:prstGeom prst="rect">
-            <a:avLst/>
-          </a:prstGeom>
-          <a:solidFill>
-            <a:srgbClr val="1273DE"/>
-          </a:solidFill>
-          <a:ln>
-            <a:noFill/>
-          </a:ln>
-        </p:spPr>
-        <p:style>
-          <a:lnRef idx="1">
-            <a:schemeClr val="accent1"/>
-          </a:lnRef>
-          <a:fillRef idx="3">
-            <a:schemeClr val="accent1"/>
-          </a:fillRef>
-          <a:effectRef idx="2">
-            <a:schemeClr val="accent1"/>
-          </a:effectRef>
-          <a:fontRef idx="minor">
-            <a:schemeClr val="lt1"/>
-          </a:fontRef>
-        </p:style>
-        <p:txBody>
-          <a:bodyPr rtlCol="0" anchor="ctr"/>
-          <a:lstStyle/>
-          <a:p>
-            <a:pPr algn="ctr"/>
-          </a:p>
-        </p:txBody>
-      </p:sp>
-      <p:sp>
-        <p:nvSpPr>
-          <p:cNvPr id="3" name="TextBox 2"/>
-          <p:cNvSpPr txBox="1"/>
-          <p:nvPr/>
-        </p:nvSpPr>
-        <p:spPr>
-          <a:xfrm>
-            <a:off x="612648" y="329184"/>
-            <a:ext cx="10479024" cy="274320"/>
-          </a:xfrm>
-          <a:prstGeom prst="rect">
-            <a:avLst/>
-          </a:prstGeom>
-          <a:noFill/>
-        </p:spPr>
-        <p:txBody>
-          <a:bodyPr wrap="square" anchor="t" lIns="45720" rIns="45720">
-            <a:spAutoFit/>
-          </a:bodyPr>
-          <a:lstStyle/>
-          <a:p>
-            <a:pPr algn="l">
-              <a:spcAft>
-                <a:spcPts val="719"/>
-              </a:spcAft>
-            </a:pPr>
-            <a:r>
-              <a:rPr sz="1200" b="1">
-                <a:solidFill>
-                  <a:srgbClr val="1273DE"/>
-                </a:solidFill>
-                <a:latin typeface="Calibri"/>
-              </a:rPr>
-              <a:t>GUT ZU WISSEN · VERSCHIEBEN UND NACHBEREITUNG</a:t>
-            </a:r>
-          </a:p>
-        </p:txBody>
-      </p:sp>
-      <p:sp>
-        <p:nvSpPr>
-          <p:cNvPr id="4" name="TextBox 3"/>
-          <p:cNvSpPr txBox="1"/>
-          <p:nvPr/>
-        </p:nvSpPr>
-        <p:spPr>
-          <a:xfrm>
-            <a:off x="612648" y="731520"/>
-            <a:ext cx="10936224" cy="640080"/>
-          </a:xfrm>
-          <a:prstGeom prst="rect">
-            <a:avLst/>
-          </a:prstGeom>
-          <a:noFill/>
-        </p:spPr>
-        <p:txBody>
-          <a:bodyPr wrap="square" anchor="t" lIns="45720" rIns="45720">
-            <a:spAutoFit/>
-          </a:bodyPr>
-          <a:lstStyle/>
-          <a:p>
-            <a:pPr algn="l">
-              <a:spcAft>
-                <a:spcPts val="1709"/>
-              </a:spcAft>
-            </a:pPr>
-            <a:r>
-              <a:rPr sz="2850" b="1">
-                <a:solidFill>
-                  <a:srgbClr val="111111"/>
-                </a:solidFill>
-                <a:latin typeface="Calibri"/>
-              </a:rPr>
-              <a:t>Regeln auf einen Blick</a:t>
-            </a:r>
-          </a:p>
-        </p:txBody>
-      </p:sp>
-      <p:sp>
-        <p:nvSpPr>
-          <p:cNvPr id="5" name="Rectangle 4"/>
-          <p:cNvSpPr/>
-          <p:nvPr/>
-        </p:nvSpPr>
-        <p:spPr>
-          <a:xfrm>
-            <a:off x="512064" y="1435608"/>
-            <a:ext cx="11128248" cy="9144"/>
-          </a:xfrm>
-          <a:prstGeom prst="rect">
-            <a:avLst/>
-          </a:prstGeom>
-          <a:solidFill>
-            <a:srgbClr val="B8BCC4"/>
-          </a:solidFill>
-          <a:ln>
-            <a:noFill/>
-          </a:ln>
-        </p:spPr>
-        <p:style>
-          <a:lnRef idx="1">
-            <a:schemeClr val="accent1"/>
-          </a:lnRef>
-          <a:fillRef idx="3">
-            <a:schemeClr val="accent1"/>
-          </a:fillRef>
-          <a:effectRef idx="2">
-            <a:schemeClr val="accent1"/>
-          </a:effectRef>
-          <a:fontRef idx="minor">
-            <a:schemeClr val="lt1"/>
-          </a:fontRef>
-        </p:style>
-        <p:txBody>
-          <a:bodyPr rtlCol="0" anchor="ctr"/>
-          <a:lstStyle/>
-          <a:p>
-            <a:pPr algn="ctr"/>
-          </a:p>
-        </p:txBody>
-      </p:sp>
-      <p:sp>
-        <p:nvSpPr>
-          <p:cNvPr id="6" name="TextBox 5"/>
-          <p:cNvSpPr txBox="1"/>
-          <p:nvPr/>
-        </p:nvSpPr>
-        <p:spPr>
-          <a:xfrm>
-            <a:off x="612648" y="6419088"/>
-            <a:ext cx="6190488" cy="274320"/>
-          </a:xfrm>
-          <a:prstGeom prst="rect">
-            <a:avLst/>
-          </a:prstGeom>
-          <a:noFill/>
-        </p:spPr>
-        <p:txBody>
-          <a:bodyPr wrap="square" anchor="t" lIns="45720" rIns="45720">
-            <a:spAutoFit/>
-          </a:bodyPr>
-          <a:lstStyle/>
-          <a:p>
-            <a:pPr algn="l">
-              <a:spcAft>
-                <a:spcPts val="630"/>
-              </a:spcAft>
-            </a:pPr>
-            <a:r>
-              <a:rPr sz="1050" b="0">
-                <a:solidFill>
-                  <a:srgbClr val="5F6368"/>
-                </a:solidFill>
-                <a:latin typeface="Calibri"/>
-              </a:rPr>
-              <a:t>RheinGedeck · Intern</a:t>
-            </a:r>
-          </a:p>
-        </p:txBody>
-      </p:sp>
-      <p:sp>
-        <p:nvSpPr>
-          <p:cNvPr id="7" name="TextBox 6"/>
-          <p:cNvSpPr txBox="1"/>
-          <p:nvPr/>
-        </p:nvSpPr>
-        <p:spPr>
-          <a:xfrm>
-            <a:off x="11009376" y="6419088"/>
-            <a:ext cx="530352" cy="274320"/>
-          </a:xfrm>
-          <a:prstGeom prst="rect">
-            <a:avLst/>
-          </a:prstGeom>
-          <a:noFill/>
-        </p:spPr>
-        <p:txBody>
-          <a:bodyPr wrap="square" anchor="t" lIns="45720" rIns="45720">
-            <a:spAutoFit/>
-          </a:bodyPr>
-          <a:lstStyle/>
-          <a:p>
-            <a:pPr algn="r">
-              <a:spcAft>
-                <a:spcPts val="630"/>
-              </a:spcAft>
-            </a:pPr>
-            <a:r>
-              <a:rPr sz="1050" b="0">
-                <a:solidFill>
-                  <a:srgbClr val="5F6368"/>
-                </a:solidFill>
-                <a:latin typeface="Calibri"/>
-              </a:rPr>
-              <a:t>08</a:t>
-            </a:r>
-          </a:p>
-        </p:txBody>
-      </p:sp>
       <p:graphicFrame>
         <p:nvGraphicFramePr>
           <p:cNvPr id="8" name="Table 7"/>
@@ -6578,7 +5677,7 @@
         </p:nvGraphicFramePr>
         <p:xfrm>
           <a:off x="685800" y="1737360"/>
-          <a:ext cx="10789920" cy="3291839"/>
+          <a:ext cx="10789920" cy="2194560"/>
         </p:xfrm>
         <a:graphic>
           <a:graphicData uri="http://schemas.openxmlformats.org/drawingml/2006/table">
@@ -6590,7 +5689,7 @@
                 <a:gridCol w="3017520"/>
                 <a:gridCol w="7772400"/>
               </a:tblGrid>
-              <a:tr h="548639">
+              <a:tr h="548640">
                 <a:tc>
                   <a:txBody>
                     <a:bodyPr/>
@@ -6636,7 +5735,7 @@
                   </a:tcPr>
                 </a:tc>
               </a:tr>
-              <a:tr h="548639">
+              <a:tr h="548640">
                 <a:tc>
                   <a:txBody>
                     <a:bodyPr/>
@@ -6682,7 +5781,7 @@
                   </a:tcPr>
                 </a:tc>
               </a:tr>
-              <a:tr h="548639">
+              <a:tr h="548640">
                 <a:tc>
                   <a:txBody>
                     <a:bodyPr/>
@@ -6728,7 +5827,7 @@
                   </a:tcPr>
                 </a:tc>
               </a:tr>
-              <a:tr h="548639">
+              <a:tr h="548640">
                 <a:tc>
                   <a:txBody>
                     <a:bodyPr/>
@@ -6774,98 +5873,6 @@
                   </a:tcPr>
                 </a:tc>
               </a:tr>
-              <a:tr h="548639">
-                <a:tc>
-                  <a:txBody>
-                    <a:bodyPr/>
-                    <a:lstStyle/>
-                    <a:p>
-                      <a:r>
-                        <a:rPr sz="1400" b="1">
-                          <a:solidFill>
-                            <a:srgbClr val="1273DE"/>
-                          </a:solidFill>
-                          <a:latin typeface="Calibri"/>
-                        </a:rPr>
-                        <a:t>Gruppengröße</a:t>
-                      </a:r>
-                    </a:p>
-                  </a:txBody>
-                  <a:tcPr marL="109728" marT="45720" marB="45720">
-                    <a:solidFill>
-                      <a:srgbClr val="F1F3F5"/>
-                    </a:solidFill>
-                  </a:tcPr>
-                </a:tc>
-                <a:tc>
-                  <a:txBody>
-                    <a:bodyPr/>
-                    <a:lstStyle/>
-                    <a:p>
-                      <a:r>
-                        <a:rPr sz="1400" b="0">
-                          <a:solidFill>
-                            <a:srgbClr val="111111"/>
-                          </a:solidFill>
-                          <a:latin typeface="Calibri"/>
-                        </a:rPr>
-                        <a:t>Für kleinere Gruppen beim Termin eine kleinere Platzzahl eintragen. Ist der Termin voll, landet niemand mehr darin.</a:t>
-                      </a:r>
-                    </a:p>
-                  </a:txBody>
-                  <a:tcPr marL="109728" marT="45720" marB="45720">
-                    <a:solidFill>
-                      <a:srgbClr val="F1F3F5"/>
-                    </a:solidFill>
-                  </a:tcPr>
-                </a:tc>
-              </a:tr>
-              <a:tr h="548644">
-                <a:tc>
-                  <a:txBody>
-                    <a:bodyPr/>
-                    <a:lstStyle/>
-                    <a:p>
-                      <a:r>
-                        <a:rPr sz="1400" b="1">
-                          <a:solidFill>
-                            <a:srgbClr val="1273DE"/>
-                          </a:solidFill>
-                          <a:latin typeface="Calibri"/>
-                        </a:rPr>
-                        <a:t>Vertragsdaten</a:t>
-                      </a:r>
-                    </a:p>
-                  </a:txBody>
-                  <a:tcPr marL="109728" marT="45720" marB="45720">
-                    <a:solidFill>
-                      <a:srgbClr val="FFFFFF"/>
-                    </a:solidFill>
-                  </a:tcPr>
-                </a:tc>
-                <a:tc>
-                  <a:txBody>
-                    <a:bodyPr/>
-                    <a:lstStyle/>
-                    <a:p>
-                      <a:r>
-                        <a:rPr sz="1400" b="0">
-                          <a:solidFill>
-                            <a:srgbClr val="111111"/>
-                          </a:solidFill>
-                          <a:latin typeface="Calibri"/>
-                        </a:rPr>
-                        <a:t>Leert ihr den Vertragsbeginn bei jemandem, der für den Versand vorgemerkt ist, wird die Vormerkung zurückgenommen. Nach dem Versand gelten die Daten im Vertrag.</a:t>
-                      </a:r>
-                    </a:p>
-                  </a:txBody>
-                  <a:tcPr marL="109728" marT="45720" marB="45720">
-                    <a:solidFill>
-                      <a:srgbClr val="FFFFFF"/>
-                    </a:solidFill>
-                  </a:tcPr>
-                </a:tc>
-              </a:tr>
             </a:tbl>
           </a:graphicData>
         </a:graphic>
@@ -6878,7 +5885,7 @@
 </p:sld>
 </file>
 
-<file path=ppt/slides/slide9.xml><?xml version="1.0" encoding="utf-8"?>
+<file path=ppt/slides/slide7.xml><?xml version="1.0" encoding="utf-8"?>
 <p:sld xmlns:a="http://schemas.openxmlformats.org/drawingml/2006/main" xmlns:p="http://schemas.openxmlformats.org/presentationml/2006/main" xmlns:r="http://schemas.openxmlformats.org/officeDocument/2006/relationships">
   <p:cSld>
     <p:spTree>
@@ -7125,7 +6132,7 @@
                 </a:solidFill>
                 <a:latin typeface="Calibri"/>
               </a:rPr>
-              <a:t>09</a:t>
+              <a:t>07</a:t>
             </a:r>
           </a:p>
         </p:txBody>

</xml_diff>

<commit_message>
docs(recruiting): Kampagnen-Teil der Anleitung in Alltagssprache (ohne Pille/Badge/Chip/Anlass-Karte)
Co-Authored-By: Claude Opus 5.5 <noreply@anthropic.com>
</commit_message>
<xml_diff>
--- a/docs/anleitungen/folien/2026-10-08-schulungstermine-umplanen.pptx
+++ b/docs/anleitungen/folien/2026-10-08-schulungstermine-umplanen.pptx
@@ -4732,7 +4732,7 @@
                 </a:solidFill>
                 <a:latin typeface="Calibri"/>
               </a:rPr>
-              <a:t>Ist ein kommender Termin ausgebucht, schreibt ihr mit einem Klick alle Bewerber dieser Ausschreibung ohne Termin an. Sie bekommen eine WhatsApp mit dem Link zur Terminauswahl und buchen sich selbst in einen anderen Termin.</a:t>
+              <a:t>Ist eine Schulung ausgebucht, könnt ihr alle Bewerber, die noch keinen Termin haben, per WhatsApp auf die freien Termine hinweisen. Sie suchen sich dann selbst einen neuen Termin aus.</a:t>
             </a:r>
           </a:p>
         </p:txBody>
@@ -4771,7 +4771,7 @@
                 </a:solidFill>
                 <a:latin typeface="Calibri"/>
               </a:rPr>
-              <a:t>1. </a:t>
+              <a:t>1. Links auf </a:t>
             </a:r>
             <a:r>
               <a:rPr sz="1800" b="1">
@@ -4789,7 +4789,7 @@
                 </a:solidFill>
                 <a:latin typeface="Calibri"/>
               </a:rPr>
-              <a:t> öffnen, Filiale wählen, nach unten zur Tabelle </a:t>
+              <a:t> gehen, eure Filiale auswählen und nach unten zu </a:t>
             </a:r>
             <a:r>
               <a:rPr sz="1800" b="1">
@@ -4823,7 +4823,7 @@
                 </a:solidFill>
                 <a:latin typeface="Calibri"/>
               </a:rPr>
-              <a:t>2. Am vollen Termin steht in der Spalte Ausschreibung das Badge </a:t>
+              <a:t>2. Bei der vollen Schulung steht </a:t>
             </a:r>
             <a:r>
               <a:rPr sz="1800" b="1">
@@ -4841,7 +4841,7 @@
                 </a:solidFill>
                 <a:latin typeface="Calibri"/>
               </a:rPr>
-              <a:t> und daneben die Pille </a:t>
+              <a:t>. Daneben seht ihr, wie viele Bewerber noch keinen Termin haben, zum Beispiel </a:t>
             </a:r>
             <a:r>
               <a:rPr sz="1800" b="1">
@@ -4850,7 +4850,7 @@
                 </a:solidFill>
                 <a:latin typeface="Calibri"/>
               </a:rPr>
-              <a:t>„N ohne Termin“</a:t>
+              <a:t>„12 ohne Termin“</a:t>
             </a:r>
             <a:r>
               <a:rPr sz="1800" b="0">
@@ -4859,7 +4859,7 @@
                 </a:solidFill>
                 <a:latin typeface="Calibri"/>
               </a:rPr>
-              <a:t>. Auf die Pille klicken.</a:t>
+              <a:t>. Darauf klicken.</a:t>
             </a:r>
           </a:p>
         </p:txBody>
@@ -4898,7 +4898,7 @@
                 </a:solidFill>
                 <a:latin typeface="Calibri"/>
               </a:rPr>
-              <a:t>3. Oben im Fenster steht der Anlass: welcher Termin voll ist und wie viele weitere Termine mit freien Plätzen es an dieser Stelle gibt. </a:t>
+              <a:t>3. Es öffnet sich ein Fenster. Oben steht, welche Schulung voll ist und ob es noch andere Termine mit freien Plätzen gibt. </a:t>
             </a:r>
             <a:r>
               <a:rPr sz="1800" b="1">
@@ -4907,7 +4907,7 @@
                 </a:solidFill>
                 <a:latin typeface="Calibri"/>
               </a:rPr>
-              <a:t>Ist die Karte rot, gibt es keine Alternative.</a:t>
+              <a:t>Ist der Kasten rot, gibt es keinen freien Termin.</a:t>
             </a:r>
             <a:r>
               <a:rPr sz="1800" b="0">
@@ -4916,7 +4916,7 @@
                 </a:solidFill>
                 <a:latin typeface="Calibri"/>
               </a:rPr>
-              <a:t> Dann erst einen neuen Termin anlegen.</a:t>
+              <a:t> Dann bitte zuerst einen neuen Termin anlegen.</a:t>
             </a:r>
           </a:p>
         </p:txBody>
@@ -4955,7 +4955,7 @@
                 </a:solidFill>
                 <a:latin typeface="Calibri"/>
               </a:rPr>
-              <a:t>Die Pille erscheint nur bei Platzzahl, voll belegt, künftigem Termin und hinterlegter Ausschreibung. Fehlt die Ausschreibung, steht nur das Badge mit „keine Ausschreibung“.</a:t>
+              <a:t>„… ohne Termin“ erscheint nur, wenn die Schulung eine Platzzahl hat, komplett voll ist, noch bevorsteht und eine Ausschreibung hinterlegt ist.</a:t>
             </a:r>
           </a:p>
         </p:txBody>
@@ -5094,7 +5094,7 @@
                 </a:solidFill>
                 <a:latin typeface="Calibri"/>
               </a:rPr>
-              <a:t>Empfänger prüfen und senden</a:t>
+              <a:t>Empfänger prüfen und WhatsApp senden</a:t>
             </a:r>
           </a:p>
         </p:txBody>
@@ -5254,7 +5254,7 @@
                 </a:solidFill>
                 <a:latin typeface="Calibri"/>
               </a:rPr>
-              <a:t>4. Die Liste zeigt die Bewerber. Jede angehakte Zeile trägt den Chip </a:t>
+              <a:t>4. Im Fenster seht ihr alle Bewerber, die die Nachricht bekommen. Wer keine bekommen soll: einfach den </a:t>
             </a:r>
             <a:r>
               <a:rPr sz="1800" b="1">
@@ -5263,7 +5263,7 @@
                 </a:solidFill>
                 <a:latin typeface="Calibri"/>
               </a:rPr>
-              <a:t>„bekommt: Termine ansehen“</a:t>
+              <a:t>Haken entfernen</a:t>
             </a:r>
             <a:r>
               <a:rPr sz="1800" b="0">
@@ -5272,7 +5272,7 @@
                 </a:solidFill>
                 <a:latin typeface="Calibri"/>
               </a:rPr>
-              <a:t>. Wer nicht angeschrieben werden soll: Haken raus. Graue Zeilen sind gesperrt, der Grund steht daneben.</a:t>
+              <a:t>. Grau hinterlegte Personen können nicht angeschrieben werden, der Grund steht dabei.</a:t>
             </a:r>
           </a:p>
           <a:p>
@@ -5288,7 +5288,7 @@
                 </a:solidFill>
                 <a:latin typeface="Calibri"/>
               </a:rPr>
-              <a:t>5. Unten steht die Nachricht so, wie der Bewerber sie liest, mit „Anna“ als Beispielname. Beim Versand steht dort der echte Vorname. Über </a:t>
+              <a:t>5. Ganz unten seht ihr die Nachricht so, wie der Bewerber sie bekommt. Statt „Anna“ steht dort später der richtige Vorname. Über </a:t>
             </a:r>
             <a:r>
               <a:rPr sz="1800" b="1">
@@ -5306,7 +5306,7 @@
                 </a:solidFill>
                 <a:latin typeface="Calibri"/>
               </a:rPr>
-              <a:t> wählt ihr eine andere Vorlage.</a:t>
+              <a:t> könnt ihr einen anderen Text wählen.</a:t>
             </a:r>
           </a:p>
         </p:txBody>
@@ -5354,7 +5354,7 @@
                 </a:solidFill>
                 <a:latin typeface="Calibri"/>
               </a:rPr>
-              <a:t>„WhatsApp an N Personen senden“</a:t>
+              <a:t>„WhatsApp an … Personen senden“</a:t>
             </a:r>
             <a:r>
               <a:rPr sz="1800" b="0">
@@ -5363,7 +5363,7 @@
                 </a:solidFill>
                 <a:latin typeface="Calibri"/>
               </a:rPr>
-              <a:t> klicken und die Nachfrage bestätigen. Der Fortschritt läuft im Fenster mit.</a:t>
+              <a:t> klicken und bestätigen. Im Fenster seht ihr, wie die Nachrichten rausgehen.</a:t>
             </a:r>
           </a:p>
         </p:txBody>

</xml_diff>

<commit_message>
docs(recruiting): Anleitung ohne Hinweis auf 'Vorlage aendern' (eine feste Vorlage)
Co-Authored-By: Claude Opus 5.5 <noreply@anthropic.com>
</commit_message>
<xml_diff>
--- a/docs/anleitungen/folien/2026-10-08-schulungstermine-umplanen.pptx
+++ b/docs/anleitungen/folien/2026-10-08-schulungstermine-umplanen.pptx
@@ -5288,25 +5288,7 @@
                 </a:solidFill>
                 <a:latin typeface="Calibri"/>
               </a:rPr>
-              <a:t>5. Ganz unten seht ihr die Nachricht so, wie der Bewerber sie bekommt. Statt „Anna“ steht dort später der richtige Vorname. Über </a:t>
-            </a:r>
-            <a:r>
-              <a:rPr sz="1800" b="1">
-                <a:solidFill>
-                  <a:srgbClr val="111111"/>
-                </a:solidFill>
-                <a:latin typeface="Calibri"/>
-              </a:rPr>
-              <a:t>„Vorlage ändern“</a:t>
-            </a:r>
-            <a:r>
-              <a:rPr sz="1800" b="0">
-                <a:solidFill>
-                  <a:srgbClr val="111111"/>
-                </a:solidFill>
-                <a:latin typeface="Calibri"/>
-              </a:rPr>
-              <a:t> könnt ihr einen anderen Text wählen.</a:t>
+              <a:t>5. Ganz unten seht ihr die Nachricht so, wie der Bewerber sie bekommt. Statt „Anna“ steht dort später der richtige Vorname.</a:t>
             </a:r>
           </a:p>
         </p:txBody>

</xml_diff>

<commit_message>
docs(recruiting): Anleitung — Verschieben am selben Tag jederzeit, auch nachtraeglich
Co-Authored-By: Claude Opus 5.5 <noreply@anthropic.com>
</commit_message>
<xml_diff>
--- a/docs/anleitungen/folien/2026-10-08-schulungstermine-umplanen.pptx
+++ b/docs/anleitungen/folien/2026-10-08-schulungstermine-umplanen.pptx
@@ -3495,7 +3495,7 @@
                 </a:solidFill>
                 <a:latin typeface="Calibri"/>
               </a:rPr>
-              <a:t>Geht vorher und auch während der Schulung.</a:t>
+              <a:t>Geht vor, während und nach der Schulung.</a:t>
             </a:r>
           </a:p>
         </p:txBody>
@@ -4077,7 +4077,7 @@
                 </a:solidFill>
                 <a:latin typeface="Calibri"/>
               </a:rPr>
-              <a:t>TEILNEHMER VERSCHIEBEN · WÄHREND DER SCHULUNG</a:t>
+              <a:t>TEILNEHMER VERSCHIEBEN · WÄHREND UND NACH DER SCHULUNG</a:t>
             </a:r>
           </a:p>
         </p:txBody>
@@ -4276,7 +4276,7 @@
                 </a:solidFill>
                 <a:latin typeface="Calibri"/>
               </a:rPr>
-              <a:t>Verschieben geht auch, solange der Termin läuft, und auch mit Teilnehmern, die schon auf </a:t>
+              <a:t>Zwischen Terminen am selben Tag könnt ihr jederzeit verschieben, auch während der Schulung und nachträglich, und auch mit Teilnehmern, die schon auf </a:t>
             </a:r>
             <a:r>
               <a:rPr sz="1800" b="1">
@@ -4294,7 +4294,7 @@
                 </a:solidFill>
                 <a:latin typeface="Calibri"/>
               </a:rPr>
-              <a:t> stehen. In der großen Gruppe alle Anwesenden auf Teilgenommen setzen, danach in die Gruppen verschieben. Der Status wandert mit.</a:t>
+              <a:t> stehen. Am besten in der großen Gruppe alle Anwesenden auf Teilgenommen setzen, danach in die Gruppen verschieben. Der Status wandert mit.</a:t>
             </a:r>
           </a:p>
         </p:txBody>
@@ -4378,7 +4378,7 @@
                 </a:solidFill>
                 <a:latin typeface="Calibri"/>
               </a:rPr>
-              <a:t>Bis der Zieltermin zu Ende ist</a:t>
+              <a:t>Am selben Tag jederzeit, auch nachträglich</a:t>
             </a:r>
           </a:p>
           <a:p>
@@ -5706,7 +5706,7 @@
                           </a:solidFill>
                           <a:latin typeface="Calibri"/>
                         </a:rPr>
-                        <a:t>Nur aktive Termine derselben Stelle (gleicher Ort), die noch nicht zu Ende sind. Ein laufender Termin geht also noch. Wer in eine andere Filiale soll, bucht über die Terminauswahl neu.</a:t>
+                        <a:t>Nur aktive Termine derselben Stelle (gleicher Ort). Termine am selben Tag jederzeit, auch nachträglich. Termine an anderen Tagen nur, solange sie noch nicht zu Ende sind. Wer in eine andere Filiale soll, bucht über die Terminauswahl neu.</a:t>
                       </a:r>
                     </a:p>
                   </a:txBody>

</xml_diff>